<commit_message>
Updated project locations of the examples ...
</commit_message>
<xml_diff>
--- a/lectures/Week06_File_Threads/1_BasicFileIO_AdvFileIOandSerialize_V4.pptx
+++ b/lectures/Week06_File_Threads/1_BasicFileIO_AdvFileIOandSerialize_V4.pptx
@@ -77,25 +77,25 @@
     <p:sldId id="373" r:id="rId65"/>
     <p:sldId id="376" r:id="rId66"/>
     <p:sldId id="374" r:id="rId67"/>
-    <p:sldId id="411" r:id="rId68"/>
-    <p:sldId id="397" r:id="rId69"/>
-    <p:sldId id="398" r:id="rId70"/>
-    <p:sldId id="399" r:id="rId71"/>
-    <p:sldId id="400" r:id="rId72"/>
-    <p:sldId id="428" r:id="rId73"/>
-    <p:sldId id="401" r:id="rId74"/>
-    <p:sldId id="434" r:id="rId75"/>
-    <p:sldId id="378" r:id="rId76"/>
-    <p:sldId id="379" r:id="rId77"/>
-    <p:sldId id="410" r:id="rId78"/>
-    <p:sldId id="390" r:id="rId79"/>
-    <p:sldId id="391" r:id="rId80"/>
-    <p:sldId id="392" r:id="rId81"/>
-    <p:sldId id="393" r:id="rId82"/>
-    <p:sldId id="395" r:id="rId83"/>
-    <p:sldId id="394" r:id="rId84"/>
-    <p:sldId id="336" r:id="rId85"/>
-    <p:sldId id="509" r:id="rId86"/>
+    <p:sldId id="509" r:id="rId68"/>
+    <p:sldId id="411" r:id="rId69"/>
+    <p:sldId id="397" r:id="rId70"/>
+    <p:sldId id="398" r:id="rId71"/>
+    <p:sldId id="399" r:id="rId72"/>
+    <p:sldId id="400" r:id="rId73"/>
+    <p:sldId id="428" r:id="rId74"/>
+    <p:sldId id="401" r:id="rId75"/>
+    <p:sldId id="434" r:id="rId76"/>
+    <p:sldId id="378" r:id="rId77"/>
+    <p:sldId id="379" r:id="rId78"/>
+    <p:sldId id="410" r:id="rId79"/>
+    <p:sldId id="390" r:id="rId80"/>
+    <p:sldId id="391" r:id="rId81"/>
+    <p:sldId id="392" r:id="rId82"/>
+    <p:sldId id="393" r:id="rId83"/>
+    <p:sldId id="395" r:id="rId84"/>
+    <p:sldId id="394" r:id="rId85"/>
+    <p:sldId id="336" r:id="rId86"/>
   </p:sldIdLst>
   <p:sldSz cx="12192000" cy="6858000"/>
   <p:notesSz cx="7010400" cy="9296400"/>
@@ -284,7 +284,7 @@
           <a:p>
             <a:fld id="{8E938536-29D3-49BD-A567-41CAF057586A}" type="datetimeFigureOut">
               <a:rPr lang="en-US" smtClean="0"/>
-              <a:t>10/26/2026</a:t>
+              <a:t>10/27/2026</a:t>
             </a:fld>
             <a:endParaRPr lang="en-US"/>
           </a:p>
@@ -449,7 +449,7 @@
           <a:p>
             <a:fld id="{71559A16-B3AD-4CE2-9A5E-FAAD3C2C27CA}" type="datetimeFigureOut">
               <a:rPr lang="en-US" smtClean="0"/>
-              <a:t>10/26/2026</a:t>
+              <a:t>10/27/2026</a:t>
             </a:fld>
             <a:endParaRPr lang="en-US"/>
           </a:p>
@@ -2204,7 +2204,7 @@
               <a:pPr>
                 <a:defRPr/>
               </a:pPr>
-              <a:t>10/26/2026</a:t>
+              <a:t>10/27/2026</a:t>
             </a:fld>
             <a:endParaRPr lang="en-US"/>
           </a:p>
@@ -5955,7 +5955,7 @@
         <p:spPr>
           <a:xfrm>
             <a:off x="936516" y="0"/>
-            <a:ext cx="8627079" cy="360606"/>
+            <a:ext cx="9442518" cy="360606"/>
           </a:xfrm>
           <a:prstGeom prst="rect">
             <a:avLst/>
@@ -6179,7 +6179,23 @@
                 <a:latin typeface="+mn-lt"/>
                 <a:ea typeface="+mn-ea"/>
               </a:rPr>
-              <a:t>“CSEN160_06_Lecture_FileIO_AdvancedFileIO_Serialize.scu.csen160.</a:t>
+              <a:t>CSEN160_06_Lecture_FileIO_AdvancedFileIO_Serialize.scu.csen160.</a:t>
+            </a:r>
+            <a:r>
+              <a:rPr lang="en-US" sz="1400" dirty="0">
+                <a:solidFill>
+                  <a:srgbClr val="FF0000"/>
+                </a:solidFill>
+              </a:rPr>
+              <a:t> </a:t>
+            </a:r>
+            <a:r>
+              <a:rPr lang="en-US" sz="1400" dirty="0" err="1">
+                <a:solidFill>
+                  <a:srgbClr val="FF0000"/>
+                </a:solidFill>
+              </a:rPr>
+              <a:t>FileIO.</a:t>
             </a:r>
             <a:r>
               <a:rPr lang="en-US" sz="1400" dirty="0" err="1">
@@ -6191,22 +6207,19 @@
               </a:rPr>
               <a:t>B_FileReaderFileWriterExample</a:t>
             </a:r>
-            <a:r>
-              <a:rPr kumimoji="0" lang="en-US" sz="1400" b="0" i="0" u="none" strike="noStrike" kern="1200" cap="none" spc="0" normalizeH="0" baseline="0" noProof="0" dirty="0">
-                <a:ln>
-                  <a:noFill/>
-                </a:ln>
-                <a:solidFill>
-                  <a:srgbClr val="FF0000"/>
-                </a:solidFill>
-                <a:effectLst/>
-                <a:uLnTx/>
-                <a:uFillTx/>
-                <a:latin typeface="+mn-lt"/>
-                <a:ea typeface="+mn-ea"/>
-              </a:rPr>
-              <a:t>”</a:t>
-            </a:r>
+            <a:endParaRPr kumimoji="0" lang="en-US" sz="1400" b="0" i="0" u="none" strike="noStrike" kern="1200" cap="none" spc="0" normalizeH="0" baseline="0" noProof="0" dirty="0">
+              <a:ln>
+                <a:noFill/>
+              </a:ln>
+              <a:solidFill>
+                <a:srgbClr val="FF0000"/>
+              </a:solidFill>
+              <a:effectLst/>
+              <a:uLnTx/>
+              <a:uFillTx/>
+              <a:latin typeface="+mn-lt"/>
+              <a:ea typeface="+mn-ea"/>
+            </a:endParaRPr>
           </a:p>
         </p:txBody>
       </p:sp>
@@ -7750,7 +7763,7 @@
         <p:spPr>
           <a:xfrm>
             <a:off x="936516" y="7552"/>
-            <a:ext cx="8532439" cy="360606"/>
+            <a:ext cx="9418767" cy="360606"/>
           </a:xfrm>
           <a:prstGeom prst="rect">
             <a:avLst/>
@@ -7974,7 +7987,31 @@
                 <a:latin typeface="+mn-lt"/>
                 <a:ea typeface="+mn-ea"/>
               </a:rPr>
-              <a:t>“CSEN160_06_Lecture_FileIO_AdvancedFileIO_Serialize.scu.csen160.</a:t>
+              <a:t>CSEN160_06_Lecture_FileIO_AdvancedFileIO_Serialize.scu.csen160.</a:t>
+            </a:r>
+            <a:r>
+              <a:rPr lang="en-US" sz="1400" dirty="0">
+                <a:solidFill>
+                  <a:srgbClr val="FF0000"/>
+                </a:solidFill>
+              </a:rPr>
+              <a:t> </a:t>
+            </a:r>
+            <a:r>
+              <a:rPr lang="en-US" sz="1400" dirty="0" err="1">
+                <a:solidFill>
+                  <a:srgbClr val="FF0000"/>
+                </a:solidFill>
+              </a:rPr>
+              <a:t>FileIO</a:t>
+            </a:r>
+            <a:r>
+              <a:rPr lang="en-US" sz="1400" dirty="0">
+                <a:solidFill>
+                  <a:srgbClr val="FF0000"/>
+                </a:solidFill>
+              </a:rPr>
+              <a:t>. </a:t>
             </a:r>
             <a:r>
               <a:rPr lang="en-US" sz="1400" dirty="0" err="1">
@@ -7986,22 +8023,19 @@
               </a:rPr>
               <a:t>C_BufferedReaderWriterExample</a:t>
             </a:r>
-            <a:r>
-              <a:rPr kumimoji="0" lang="en-US" sz="1400" b="0" i="0" u="none" strike="noStrike" kern="1200" cap="none" spc="0" normalizeH="0" baseline="0" noProof="0" dirty="0">
-                <a:ln>
-                  <a:noFill/>
-                </a:ln>
-                <a:solidFill>
-                  <a:srgbClr val="FF0000"/>
-                </a:solidFill>
-                <a:effectLst/>
-                <a:uLnTx/>
-                <a:uFillTx/>
-                <a:latin typeface="+mn-lt"/>
-                <a:ea typeface="+mn-ea"/>
-              </a:rPr>
-              <a:t>”</a:t>
-            </a:r>
+            <a:endParaRPr kumimoji="0" lang="en-US" sz="1400" b="0" i="0" u="none" strike="noStrike" kern="1200" cap="none" spc="0" normalizeH="0" baseline="0" noProof="0" dirty="0">
+              <a:ln>
+                <a:noFill/>
+              </a:ln>
+              <a:solidFill>
+                <a:srgbClr val="FF0000"/>
+              </a:solidFill>
+              <a:effectLst/>
+              <a:uLnTx/>
+              <a:uFillTx/>
+              <a:latin typeface="+mn-lt"/>
+              <a:ea typeface="+mn-ea"/>
+            </a:endParaRPr>
           </a:p>
         </p:txBody>
       </p:sp>
@@ -9277,7 +9311,23 @@
                 <a:latin typeface="+mn-lt"/>
                 <a:ea typeface="+mn-ea"/>
               </a:rPr>
-              <a:t>“CSEN160_06_Lecture_FileIO_AdvancedFileIO_Serialize.scu.csen160.</a:t>
+              <a:t>CSEN160_06_Lecture_FileIO_AdvancedFileIO_Serialize.scu.csen160.</a:t>
+            </a:r>
+            <a:r>
+              <a:rPr lang="en-US" dirty="0">
+                <a:solidFill>
+                  <a:srgbClr val="FF0000"/>
+                </a:solidFill>
+              </a:rPr>
+              <a:t> </a:t>
+            </a:r>
+            <a:r>
+              <a:rPr lang="en-US" dirty="0" err="1">
+                <a:solidFill>
+                  <a:srgbClr val="FF0000"/>
+                </a:solidFill>
+              </a:rPr>
+              <a:t>FileIO.</a:t>
             </a:r>
             <a:r>
               <a:rPr lang="en-US" dirty="0" err="1">
@@ -9289,22 +9339,19 @@
               </a:rPr>
               <a:t>D_ScannerExample</a:t>
             </a:r>
-            <a:r>
-              <a:rPr kumimoji="0" lang="en-US" sz="2600" b="0" i="0" u="none" strike="noStrike" kern="1200" cap="none" spc="0" normalizeH="0" baseline="0" noProof="0" dirty="0">
-                <a:ln>
-                  <a:noFill/>
-                </a:ln>
-                <a:solidFill>
-                  <a:srgbClr val="FF0000"/>
-                </a:solidFill>
-                <a:effectLst/>
-                <a:uLnTx/>
-                <a:uFillTx/>
-                <a:latin typeface="+mn-lt"/>
-                <a:ea typeface="+mn-ea"/>
-              </a:rPr>
-              <a:t>”</a:t>
-            </a:r>
+            <a:endParaRPr kumimoji="0" lang="en-US" sz="2600" b="0" i="0" u="none" strike="noStrike" kern="1200" cap="none" spc="0" normalizeH="0" baseline="0" noProof="0" dirty="0">
+              <a:ln>
+                <a:noFill/>
+              </a:ln>
+              <a:solidFill>
+                <a:srgbClr val="FF0000"/>
+              </a:solidFill>
+              <a:effectLst/>
+              <a:uLnTx/>
+              <a:uFillTx/>
+              <a:latin typeface="+mn-lt"/>
+              <a:ea typeface="+mn-ea"/>
+            </a:endParaRPr>
           </a:p>
         </p:txBody>
       </p:sp>
@@ -12751,7 +12798,23 @@
                 <a:latin typeface="+mn-lt"/>
                 <a:ea typeface="+mn-ea"/>
               </a:rPr>
-              <a:t>“CSEN160_06_Lecture_FileIO_AdvancedFileIO_Serialize.scu.csen160.</a:t>
+              <a:t>CSEN160_06_Lecture_FileIO_AdvancedFileIO_Serialize.scu.csen160.</a:t>
+            </a:r>
+            <a:r>
+              <a:rPr lang="en-US" dirty="0">
+                <a:solidFill>
+                  <a:srgbClr val="FF0000"/>
+                </a:solidFill>
+              </a:rPr>
+              <a:t> </a:t>
+            </a:r>
+            <a:r>
+              <a:rPr lang="en-US" dirty="0" err="1">
+                <a:solidFill>
+                  <a:srgbClr val="FF0000"/>
+                </a:solidFill>
+              </a:rPr>
+              <a:t>FileIO.</a:t>
             </a:r>
             <a:r>
               <a:rPr lang="en-US" dirty="0" err="1">
@@ -12763,22 +12826,19 @@
               </a:rPr>
               <a:t>E_RandomAccessFileExample</a:t>
             </a:r>
-            <a:r>
-              <a:rPr kumimoji="0" lang="en-US" sz="2600" b="0" i="0" u="none" strike="noStrike" kern="1200" cap="none" spc="0" normalizeH="0" baseline="0" noProof="0" dirty="0">
-                <a:ln>
-                  <a:noFill/>
-                </a:ln>
-                <a:solidFill>
-                  <a:srgbClr val="FF0000"/>
-                </a:solidFill>
-                <a:effectLst/>
-                <a:uLnTx/>
-                <a:uFillTx/>
-                <a:latin typeface="+mn-lt"/>
-                <a:ea typeface="+mn-ea"/>
-              </a:rPr>
-              <a:t>”</a:t>
-            </a:r>
+            <a:endParaRPr kumimoji="0" lang="en-US" sz="2600" b="0" i="0" u="none" strike="noStrike" kern="1200" cap="none" spc="0" normalizeH="0" baseline="0" noProof="0" dirty="0">
+              <a:ln>
+                <a:noFill/>
+              </a:ln>
+              <a:solidFill>
+                <a:srgbClr val="FF0000"/>
+              </a:solidFill>
+              <a:effectLst/>
+              <a:uLnTx/>
+              <a:uFillTx/>
+              <a:latin typeface="+mn-lt"/>
+              <a:ea typeface="+mn-ea"/>
+            </a:endParaRPr>
           </a:p>
         </p:txBody>
       </p:sp>
@@ -18328,8 +18388,8 @@
         </p:nvSpPr>
         <p:spPr>
           <a:xfrm>
-            <a:off x="1123317" y="21350"/>
-            <a:ext cx="7890091" cy="360606"/>
+            <a:off x="1123316" y="21350"/>
+            <a:ext cx="10067197" cy="360606"/>
           </a:xfrm>
           <a:prstGeom prst="rect">
             <a:avLst/>
@@ -18535,23 +18595,8 @@
             </a:lvl9pPr>
           </a:lstStyle>
           <a:p>
-            <a:pPr marL="0" marR="0" lvl="0" indent="0" algn="ctr" defTabSz="914400" rtl="0" eaLnBrk="1" fontAlgn="auto" latinLnBrk="0" hangingPunct="1">
-              <a:lnSpc>
-                <a:spcPct val="90000"/>
-              </a:lnSpc>
-              <a:spcBef>
-                <a:spcPts val="1000"/>
-              </a:spcBef>
-              <a:spcAft>
-                <a:spcPts val="0"/>
-              </a:spcAft>
-              <a:buClr>
-                <a:srgbClr val="B30738"/>
-              </a:buClr>
-              <a:buSzTx/>
-              <a:buFont typeface="Arial" panose="020B0604020202020204" pitchFamily="34" charset="0"/>
-              <a:buNone/>
-              <a:tabLst/>
+            <a:pPr marL="0" indent="0" algn="ctr">
+              <a:buNone/>
               <a:defRPr/>
             </a:pPr>
             <a:r>
@@ -18568,8 +18613,21 @@
                 <a:latin typeface="Arial" panose="020B0604020202020204"/>
                 <a:ea typeface="+mn-ea"/>
               </a:rPr>
-              <a:t>“CSEN160_06_Lecture_FileIO_AdvancedFileIO_Serialize.scu.csen160.AudioPlayer”</a:t>
-            </a:r>
+              <a:t>CSEN160_06_Lecture_FileIO_AdvancedFileIO_Serialize.scu.csen160.AudioExample.</a:t>
+            </a:r>
+            <a:r>
+              <a:rPr lang="en-US" dirty="0" err="1">
+                <a:solidFill>
+                  <a:srgbClr val="FF0000"/>
+                </a:solidFill>
+              </a:rPr>
+              <a:t>A_ShowWAVEHeader</a:t>
+            </a:r>
+            <a:endParaRPr lang="en-US" dirty="0">
+              <a:solidFill>
+                <a:srgbClr val="FF0000"/>
+              </a:solidFill>
+            </a:endParaRPr>
           </a:p>
         </p:txBody>
       </p:sp>
@@ -23725,6 +23783,70 @@
   <p:cSld>
     <p:spTree>
       <p:nvGrpSpPr>
+        <p:cNvPr id="1" name="">
+          <a:extLst>
+            <a:ext uri="{FF2B5EF4-FFF2-40B4-BE49-F238E27FC236}">
+              <a16:creationId xmlns:a16="http://schemas.microsoft.com/office/drawing/2014/main" id="{84DA25F2-3AE0-BDCF-0880-EDD5EEF55E54}"/>
+            </a:ext>
+          </a:extLst>
+        </p:cNvPr>
+        <p:cNvGrpSpPr/>
+        <p:nvPr/>
+      </p:nvGrpSpPr>
+      <p:grpSpPr>
+        <a:xfrm>
+          <a:off x="0" y="0"/>
+          <a:ext cx="0" cy="0"/>
+          <a:chOff x="0" y="0"/>
+          <a:chExt cx="0" cy="0"/>
+        </a:xfrm>
+      </p:grpSpPr>
+      <p:sp>
+        <p:nvSpPr>
+          <p:cNvPr id="2" name="Title 1">
+            <a:extLst>
+              <a:ext uri="{FF2B5EF4-FFF2-40B4-BE49-F238E27FC236}">
+                <a16:creationId xmlns:a16="http://schemas.microsoft.com/office/drawing/2014/main" id="{6EAE57A2-3A61-C5F8-EEFD-EA2961784338}"/>
+              </a:ext>
+            </a:extLst>
+          </p:cNvPr>
+          <p:cNvSpPr>
+            <a:spLocks noGrp="1"/>
+          </p:cNvSpPr>
+          <p:nvPr>
+            <p:ph type="ctrTitle"/>
+          </p:nvPr>
+        </p:nvSpPr>
+        <p:spPr/>
+        <p:txBody>
+          <a:bodyPr/>
+          <a:lstStyle/>
+          <a:p>
+            <a:r>
+              <a:rPr lang="en-US" dirty="0"/>
+              <a:t>… to here …</a:t>
+            </a:r>
+          </a:p>
+        </p:txBody>
+      </p:sp>
+    </p:spTree>
+    <p:extLst>
+      <p:ext uri="{BB962C8B-B14F-4D97-AF65-F5344CB8AC3E}">
+        <p14:creationId xmlns:p14="http://schemas.microsoft.com/office/powerpoint/2010/main" val="2815624037"/>
+      </p:ext>
+    </p:extLst>
+  </p:cSld>
+  <p:clrMapOvr>
+    <a:masterClrMapping/>
+  </p:clrMapOvr>
+</p:sld>
+</file>
+
+<file path=ppt/slides/slide67.xml><?xml version="1.0" encoding="utf-8"?>
+<p:sld xmlns:a="http://schemas.openxmlformats.org/drawingml/2006/main" xmlns:r="http://schemas.openxmlformats.org/officeDocument/2006/relationships" xmlns:p="http://schemas.openxmlformats.org/presentationml/2006/main">
+  <p:cSld>
+    <p:spTree>
+      <p:nvGrpSpPr>
         <p:cNvPr id="1" name=""/>
         <p:cNvGrpSpPr/>
         <p:nvPr/>
@@ -23786,7 +23908,7 @@
 </p:sld>
 </file>
 
-<file path=ppt/slides/slide67.xml><?xml version="1.0" encoding="utf-8"?>
+<file path=ppt/slides/slide68.xml><?xml version="1.0" encoding="utf-8"?>
 <p:sld xmlns:a="http://schemas.openxmlformats.org/drawingml/2006/main" xmlns:r="http://schemas.openxmlformats.org/officeDocument/2006/relationships" xmlns:p="http://schemas.openxmlformats.org/presentationml/2006/main">
   <p:cSld>
     <p:spTree>
@@ -23928,7 +24050,7 @@
 </p:sld>
 </file>
 
-<file path=ppt/slides/slide68.xml><?xml version="1.0" encoding="utf-8"?>
+<file path=ppt/slides/slide69.xml><?xml version="1.0" encoding="utf-8"?>
 <p:sld xmlns:a="http://schemas.openxmlformats.org/drawingml/2006/main" xmlns:r="http://schemas.openxmlformats.org/officeDocument/2006/relationships" xmlns:p="http://schemas.openxmlformats.org/presentationml/2006/main">
   <p:cSld>
     <p:spTree>
@@ -24368,697 +24490,6 @@
     <p:extLst>
       <p:ext uri="{BB962C8B-B14F-4D97-AF65-F5344CB8AC3E}">
         <p14:creationId xmlns:p14="http://schemas.microsoft.com/office/powerpoint/2010/main" val="4228337043"/>
-      </p:ext>
-    </p:extLst>
-  </p:cSld>
-  <p:clrMapOvr>
-    <a:masterClrMapping/>
-  </p:clrMapOvr>
-</p:sld>
-</file>
-
-<file path=ppt/slides/slide69.xml><?xml version="1.0" encoding="utf-8"?>
-<p:sld xmlns:a="http://schemas.openxmlformats.org/drawingml/2006/main" xmlns:r="http://schemas.openxmlformats.org/officeDocument/2006/relationships" xmlns:p="http://schemas.openxmlformats.org/presentationml/2006/main">
-  <p:cSld>
-    <p:spTree>
-      <p:nvGrpSpPr>
-        <p:cNvPr id="1" name=""/>
-        <p:cNvGrpSpPr/>
-        <p:nvPr/>
-      </p:nvGrpSpPr>
-      <p:grpSpPr>
-        <a:xfrm>
-          <a:off x="0" y="0"/>
-          <a:ext cx="0" cy="0"/>
-          <a:chOff x="0" y="0"/>
-          <a:chExt cx="0" cy="0"/>
-        </a:xfrm>
-      </p:grpSpPr>
-      <p:sp>
-        <p:nvSpPr>
-          <p:cNvPr id="2" name="Title 1"/>
-          <p:cNvSpPr>
-            <a:spLocks noGrp="1"/>
-          </p:cNvSpPr>
-          <p:nvPr>
-            <p:ph type="title"/>
-          </p:nvPr>
-        </p:nvSpPr>
-        <p:spPr>
-          <a:xfrm>
-            <a:off x="936516" y="765946"/>
-            <a:ext cx="6176383" cy="747265"/>
-          </a:xfrm>
-        </p:spPr>
-        <p:txBody>
-          <a:bodyPr/>
-          <a:lstStyle/>
-          <a:p>
-            <a:r>
-              <a:rPr lang="en-US" dirty="0"/>
-              <a:t>Class </a:t>
-            </a:r>
-            <a:r>
-              <a:rPr lang="en-US" dirty="0" err="1">
-                <a:latin typeface="Courier"/>
-                <a:cs typeface="Courier"/>
-              </a:rPr>
-              <a:t>AudioInputStream</a:t>
-            </a:r>
-            <a:endParaRPr lang="en-US" dirty="0">
-              <a:latin typeface="Courier"/>
-              <a:cs typeface="Courier"/>
-            </a:endParaRPr>
-          </a:p>
-        </p:txBody>
-      </p:sp>
-      <p:sp>
-        <p:nvSpPr>
-          <p:cNvPr id="3" name="Content Placeholder 2"/>
-          <p:cNvSpPr>
-            <a:spLocks noGrp="1"/>
-          </p:cNvSpPr>
-          <p:nvPr>
-            <p:ph idx="1"/>
-          </p:nvPr>
-        </p:nvSpPr>
-        <p:spPr>
-          <a:xfrm>
-            <a:off x="936516" y="1907219"/>
-            <a:ext cx="10404472" cy="4724204"/>
-          </a:xfrm>
-        </p:spPr>
-        <p:txBody>
-          <a:bodyPr>
-            <a:normAutofit/>
-          </a:bodyPr>
-          <a:lstStyle/>
-          <a:p>
-            <a:r>
-              <a:rPr lang="en-US" dirty="0">
-                <a:solidFill>
-                  <a:schemeClr val="tx1"/>
-                </a:solidFill>
-              </a:rPr>
-              <a:t>To</a:t>
-            </a:r>
-            <a:r>
-              <a:rPr lang="en-US" dirty="0"/>
-              <a:t> </a:t>
-            </a:r>
-            <a:r>
-              <a:rPr lang="en-US" b="1" dirty="0">
-                <a:solidFill>
-                  <a:srgbClr val="0000FF"/>
-                </a:solidFill>
-              </a:rPr>
-              <a:t>read</a:t>
-            </a:r>
-            <a:r>
-              <a:rPr lang="en-US" dirty="0">
-                <a:solidFill>
-                  <a:srgbClr val="0000FF"/>
-                </a:solidFill>
-              </a:rPr>
-              <a:t> </a:t>
-            </a:r>
-            <a:r>
-              <a:rPr lang="en-US" dirty="0">
-                <a:solidFill>
-                  <a:schemeClr val="tx1"/>
-                </a:solidFill>
-              </a:rPr>
-              <a:t>an audio file, convert it to an </a:t>
-            </a:r>
-            <a:r>
-              <a:rPr lang="en-US" b="1" dirty="0">
-                <a:solidFill>
-                  <a:schemeClr val="tx1"/>
-                </a:solidFill>
-              </a:rPr>
-              <a:t>audio stream, </a:t>
-            </a:r>
-            <a:br>
-              <a:rPr lang="en-US" b="1" dirty="0">
-                <a:solidFill>
-                  <a:schemeClr val="tx1"/>
-                </a:solidFill>
-              </a:rPr>
-            </a:br>
-            <a:r>
-              <a:rPr lang="en-US" dirty="0">
-                <a:solidFill>
-                  <a:schemeClr val="tx1"/>
-                </a:solidFill>
-              </a:rPr>
-              <a:t>using</a:t>
-            </a:r>
-            <a:r>
-              <a:rPr lang="en-US" b="1" dirty="0">
-                <a:solidFill>
-                  <a:schemeClr val="tx1"/>
-                </a:solidFill>
-              </a:rPr>
-              <a:t> </a:t>
-            </a:r>
-            <a:r>
-              <a:rPr lang="en-US" dirty="0">
-                <a:solidFill>
-                  <a:schemeClr val="tx1"/>
-                </a:solidFill>
-              </a:rPr>
-              <a:t>the </a:t>
-            </a:r>
-            <a:r>
-              <a:rPr lang="en-US" sz="2000" dirty="0" err="1">
-                <a:solidFill>
-                  <a:schemeClr val="tx1"/>
-                </a:solidFill>
-                <a:latin typeface="Courier"/>
-                <a:cs typeface="Courier"/>
-              </a:rPr>
-              <a:t>getAudioInputStream</a:t>
-            </a:r>
-            <a:r>
-              <a:rPr lang="en-US" sz="2000" dirty="0">
-                <a:solidFill>
-                  <a:schemeClr val="tx1"/>
-                </a:solidFill>
-                <a:latin typeface="Courier"/>
-                <a:cs typeface="Courier"/>
-              </a:rPr>
-              <a:t>(…)</a:t>
-            </a:r>
-            <a:r>
-              <a:rPr lang="en-US" sz="2000" dirty="0">
-                <a:solidFill>
-                  <a:schemeClr val="tx1"/>
-                </a:solidFill>
-              </a:rPr>
-              <a:t> </a:t>
-            </a:r>
-            <a:r>
-              <a:rPr lang="en-US" dirty="0">
-                <a:solidFill>
-                  <a:schemeClr val="tx1"/>
-                </a:solidFill>
-              </a:rPr>
-              <a:t>method of </a:t>
-            </a:r>
-            <a:r>
-              <a:rPr lang="en-US" sz="2000" dirty="0" err="1">
-                <a:solidFill>
-                  <a:schemeClr val="tx1"/>
-                </a:solidFill>
-                <a:latin typeface="Courier"/>
-                <a:cs typeface="Courier"/>
-              </a:rPr>
-              <a:t>AudioSystem</a:t>
-            </a:r>
-            <a:r>
-              <a:rPr lang="en-US" dirty="0">
-                <a:solidFill>
-                  <a:schemeClr val="tx1"/>
-                </a:solidFill>
-              </a:rPr>
-              <a:t>:</a:t>
-            </a:r>
-          </a:p>
-          <a:p>
-            <a:endParaRPr lang="en-US" dirty="0">
-              <a:solidFill>
-                <a:schemeClr val="tx1"/>
-              </a:solidFill>
-            </a:endParaRPr>
-          </a:p>
-          <a:p>
-            <a:endParaRPr lang="en-US" dirty="0">
-              <a:solidFill>
-                <a:schemeClr val="tx1"/>
-              </a:solidFill>
-            </a:endParaRPr>
-          </a:p>
-          <a:p>
-            <a:r>
-              <a:rPr lang="en-US" dirty="0">
-                <a:solidFill>
-                  <a:schemeClr val="tx1"/>
-                </a:solidFill>
-              </a:rPr>
-              <a:t>To</a:t>
-            </a:r>
-            <a:r>
-              <a:rPr lang="en-US" dirty="0"/>
-              <a:t> </a:t>
-            </a:r>
-            <a:r>
-              <a:rPr lang="en-US" b="1" dirty="0">
-                <a:solidFill>
-                  <a:srgbClr val="0000FF"/>
-                </a:solidFill>
-              </a:rPr>
-              <a:t>open</a:t>
-            </a:r>
-            <a:r>
-              <a:rPr lang="en-US" dirty="0">
-                <a:solidFill>
-                  <a:srgbClr val="0000FF"/>
-                </a:solidFill>
-              </a:rPr>
-              <a:t> </a:t>
-            </a:r>
-            <a:r>
-              <a:rPr lang="en-US" dirty="0">
-                <a:solidFill>
-                  <a:schemeClr val="tx1"/>
-                </a:solidFill>
-              </a:rPr>
-              <a:t>an audio stream, use </a:t>
-            </a:r>
-            <a:r>
-              <a:rPr lang="en-US" sz="2000" dirty="0" err="1">
-                <a:solidFill>
-                  <a:schemeClr val="tx1"/>
-                </a:solidFill>
-                <a:latin typeface="Courier"/>
-                <a:cs typeface="Courier"/>
-              </a:rPr>
-              <a:t>AudioInputStream</a:t>
-            </a:r>
-            <a:r>
-              <a:rPr lang="en-US" sz="2000" dirty="0">
-                <a:solidFill>
-                  <a:schemeClr val="tx1"/>
-                </a:solidFill>
-                <a:cs typeface="Courier"/>
-              </a:rPr>
-              <a:t> </a:t>
-            </a:r>
-            <a:r>
-              <a:rPr lang="en-US" dirty="0">
-                <a:solidFill>
-                  <a:schemeClr val="tx1"/>
-                </a:solidFill>
-              </a:rPr>
-              <a:t>as argument.</a:t>
-            </a:r>
-          </a:p>
-          <a:p>
-            <a:endParaRPr lang="en-US" dirty="0">
-              <a:solidFill>
-                <a:schemeClr val="tx1"/>
-              </a:solidFill>
-            </a:endParaRPr>
-          </a:p>
-          <a:p>
-            <a:r>
-              <a:rPr lang="en-US" dirty="0">
-                <a:solidFill>
-                  <a:schemeClr val="tx1"/>
-                </a:solidFill>
-              </a:rPr>
-              <a:t>To </a:t>
-            </a:r>
-            <a:r>
-              <a:rPr lang="en-US" b="1" dirty="0">
-                <a:solidFill>
-                  <a:srgbClr val="0000FF"/>
-                </a:solidFill>
-              </a:rPr>
-              <a:t>start</a:t>
-            </a:r>
-            <a:r>
-              <a:rPr lang="en-US" dirty="0">
-                <a:solidFill>
-                  <a:srgbClr val="0000FF"/>
-                </a:solidFill>
-              </a:rPr>
-              <a:t> </a:t>
-            </a:r>
-            <a:r>
-              <a:rPr lang="en-US" dirty="0">
-                <a:solidFill>
-                  <a:schemeClr val="tx1"/>
-                </a:solidFill>
-              </a:rPr>
-              <a:t>playback, use </a:t>
-            </a:r>
-            <a:r>
-              <a:rPr lang="en-US" sz="2000" dirty="0">
-                <a:solidFill>
-                  <a:schemeClr val="tx1"/>
-                </a:solidFill>
-                <a:latin typeface="Courier"/>
-                <a:cs typeface="Courier"/>
-              </a:rPr>
-              <a:t>start</a:t>
-            </a:r>
-            <a:r>
-              <a:rPr lang="en-US" sz="2000" dirty="0">
-                <a:solidFill>
-                  <a:schemeClr val="tx1"/>
-                </a:solidFill>
-              </a:rPr>
-              <a:t> </a:t>
-            </a:r>
-            <a:r>
-              <a:rPr lang="en-US" dirty="0">
-                <a:solidFill>
-                  <a:schemeClr val="tx1"/>
-                </a:solidFill>
-              </a:rPr>
-              <a:t>method:</a:t>
-            </a:r>
-          </a:p>
-        </p:txBody>
-      </p:sp>
-      <p:sp>
-        <p:nvSpPr>
-          <p:cNvPr id="6" name="Rectangle 5"/>
-          <p:cNvSpPr/>
-          <p:nvPr/>
-        </p:nvSpPr>
-        <p:spPr>
-          <a:xfrm>
-            <a:off x="2486951" y="5148558"/>
-            <a:ext cx="6629400" cy="923330"/>
-          </a:xfrm>
-          <a:prstGeom prst="rect">
-            <a:avLst/>
-          </a:prstGeom>
-          <a:solidFill>
-            <a:srgbClr val="FFFFCC"/>
-          </a:solidFill>
-          <a:ln w="3175" cmpd="sng">
-            <a:solidFill>
-              <a:schemeClr val="tx1"/>
-            </a:solidFill>
-          </a:ln>
-        </p:spPr>
-        <p:txBody>
-          <a:bodyPr wrap="square">
-            <a:spAutoFit/>
-          </a:bodyPr>
-          <a:lstStyle/>
-          <a:p>
-            <a:pPr marL="0" marR="0" lvl="0" indent="0" algn="l" defTabSz="914400" rtl="0" eaLnBrk="1" fontAlgn="auto" latinLnBrk="0" hangingPunct="1">
-              <a:lnSpc>
-                <a:spcPct val="100000"/>
-              </a:lnSpc>
-              <a:spcBef>
-                <a:spcPts val="0"/>
-              </a:spcBef>
-              <a:spcAft>
-                <a:spcPts val="0"/>
-              </a:spcAft>
-              <a:buClrTx/>
-              <a:buSzTx/>
-              <a:buFontTx/>
-              <a:buNone/>
-              <a:tabLst/>
-              <a:defRPr/>
-            </a:pPr>
-            <a:r>
-              <a:rPr kumimoji="0" lang="en-US" sz="1800" b="0" i="0" u="none" strike="noStrike" kern="1200" cap="none" spc="0" normalizeH="0" baseline="0" noProof="0" dirty="0">
-                <a:ln>
-                  <a:noFill/>
-                </a:ln>
-                <a:solidFill>
-                  <a:srgbClr val="000000"/>
-                </a:solidFill>
-                <a:effectLst/>
-                <a:uLnTx/>
-                <a:uFillTx/>
-                <a:latin typeface="Courier"/>
-                <a:ea typeface="+mn-ea"/>
-                <a:cs typeface="Courier"/>
-              </a:rPr>
-              <a:t>Clip clip = (Clip) </a:t>
-            </a:r>
-            <a:r>
-              <a:rPr kumimoji="0" lang="en-US" sz="1800" b="0" i="0" u="none" strike="noStrike" kern="1200" cap="none" spc="0" normalizeH="0" baseline="0" noProof="0" dirty="0" err="1">
-                <a:ln>
-                  <a:noFill/>
-                </a:ln>
-                <a:solidFill>
-                  <a:srgbClr val="000000"/>
-                </a:solidFill>
-                <a:effectLst/>
-                <a:uLnTx/>
-                <a:uFillTx/>
-                <a:latin typeface="Courier"/>
-                <a:ea typeface="+mn-ea"/>
-                <a:cs typeface="Courier"/>
-              </a:rPr>
-              <a:t>AudioSystem.getClip</a:t>
-            </a:r>
-            <a:r>
-              <a:rPr kumimoji="0" lang="en-US" sz="1800" b="0" i="0" u="none" strike="noStrike" kern="1200" cap="none" spc="0" normalizeH="0" baseline="0" noProof="0" dirty="0">
-                <a:ln>
-                  <a:noFill/>
-                </a:ln>
-                <a:solidFill>
-                  <a:srgbClr val="000000"/>
-                </a:solidFill>
-                <a:effectLst/>
-                <a:uLnTx/>
-                <a:uFillTx/>
-                <a:latin typeface="Courier"/>
-                <a:ea typeface="+mn-ea"/>
-                <a:cs typeface="Courier"/>
-              </a:rPr>
-              <a:t>();</a:t>
-            </a:r>
-          </a:p>
-          <a:p>
-            <a:pPr marL="0" marR="0" lvl="0" indent="0" algn="l" defTabSz="914400" rtl="0" eaLnBrk="1" fontAlgn="auto" latinLnBrk="0" hangingPunct="1">
-              <a:lnSpc>
-                <a:spcPct val="100000"/>
-              </a:lnSpc>
-              <a:spcBef>
-                <a:spcPts val="0"/>
-              </a:spcBef>
-              <a:spcAft>
-                <a:spcPts val="0"/>
-              </a:spcAft>
-              <a:buClrTx/>
-              <a:buSzTx/>
-              <a:buFontTx/>
-              <a:buNone/>
-              <a:tabLst/>
-              <a:defRPr/>
-            </a:pPr>
-            <a:r>
-              <a:rPr kumimoji="0" lang="en-US" sz="1800" b="0" i="0" u="none" strike="noStrike" kern="1200" cap="none" spc="0" normalizeH="0" baseline="0" noProof="0" dirty="0" err="1">
-                <a:ln>
-                  <a:noFill/>
-                </a:ln>
-                <a:solidFill>
-                  <a:srgbClr val="000000"/>
-                </a:solidFill>
-                <a:effectLst/>
-                <a:uLnTx/>
-                <a:uFillTx/>
-                <a:latin typeface="Courier"/>
-                <a:ea typeface="+mn-ea"/>
-                <a:cs typeface="Courier"/>
-              </a:rPr>
-              <a:t>clip.open(stream</a:t>
-            </a:r>
-            <a:r>
-              <a:rPr kumimoji="0" lang="en-US" sz="1800" b="0" i="0" u="none" strike="noStrike" kern="1200" cap="none" spc="0" normalizeH="0" baseline="0" noProof="0" dirty="0">
-                <a:ln>
-                  <a:noFill/>
-                </a:ln>
-                <a:solidFill>
-                  <a:srgbClr val="000000"/>
-                </a:solidFill>
-                <a:effectLst/>
-                <a:uLnTx/>
-                <a:uFillTx/>
-                <a:latin typeface="Courier"/>
-                <a:ea typeface="+mn-ea"/>
-                <a:cs typeface="Courier"/>
-              </a:rPr>
-              <a:t>); 	// open the audio stream</a:t>
-            </a:r>
-          </a:p>
-          <a:p>
-            <a:pPr marL="0" marR="0" lvl="0" indent="0" algn="l" defTabSz="914400" rtl="0" eaLnBrk="1" fontAlgn="auto" latinLnBrk="0" hangingPunct="1">
-              <a:lnSpc>
-                <a:spcPct val="100000"/>
-              </a:lnSpc>
-              <a:spcBef>
-                <a:spcPts val="0"/>
-              </a:spcBef>
-              <a:spcAft>
-                <a:spcPts val="0"/>
-              </a:spcAft>
-              <a:buClrTx/>
-              <a:buSzTx/>
-              <a:buFontTx/>
-              <a:buNone/>
-              <a:tabLst/>
-              <a:defRPr/>
-            </a:pPr>
-            <a:r>
-              <a:rPr kumimoji="0" lang="en-US" sz="1800" b="0" i="0" u="none" strike="noStrike" kern="1200" cap="none" spc="0" normalizeH="0" baseline="0" noProof="0" dirty="0" err="1">
-                <a:ln>
-                  <a:noFill/>
-                </a:ln>
-                <a:solidFill>
-                  <a:srgbClr val="000000"/>
-                </a:solidFill>
-                <a:effectLst/>
-                <a:uLnTx/>
-                <a:uFillTx/>
-                <a:latin typeface="Courier"/>
-                <a:ea typeface="+mn-ea"/>
-                <a:cs typeface="Courier"/>
-              </a:rPr>
-              <a:t>clip.start</a:t>
-            </a:r>
-            <a:r>
-              <a:rPr kumimoji="0" lang="en-US" sz="1800" b="0" i="0" u="none" strike="noStrike" kern="1200" cap="none" spc="0" normalizeH="0" baseline="0" noProof="0" dirty="0">
-                <a:ln>
-                  <a:noFill/>
-                </a:ln>
-                <a:solidFill>
-                  <a:srgbClr val="000000"/>
-                </a:solidFill>
-                <a:effectLst/>
-                <a:uLnTx/>
-                <a:uFillTx/>
-                <a:latin typeface="Courier"/>
-                <a:ea typeface="+mn-ea"/>
-                <a:cs typeface="Courier"/>
-              </a:rPr>
-              <a:t>(); 	// start playing the audio</a:t>
-            </a:r>
-          </a:p>
-        </p:txBody>
-      </p:sp>
-      <p:sp>
-        <p:nvSpPr>
-          <p:cNvPr id="7" name="Rectangle 6"/>
-          <p:cNvSpPr/>
-          <p:nvPr/>
-        </p:nvSpPr>
-        <p:spPr>
-          <a:xfrm>
-            <a:off x="1212455" y="2911469"/>
-            <a:ext cx="9655147" cy="369332"/>
-          </a:xfrm>
-          <a:prstGeom prst="rect">
-            <a:avLst/>
-          </a:prstGeom>
-          <a:solidFill>
-            <a:srgbClr val="FFFFCC"/>
-          </a:solidFill>
-          <a:ln w="3175" cmpd="sng">
-            <a:solidFill>
-              <a:schemeClr val="tx1"/>
-            </a:solidFill>
-          </a:ln>
-        </p:spPr>
-        <p:txBody>
-          <a:bodyPr wrap="square">
-            <a:spAutoFit/>
-          </a:bodyPr>
-          <a:lstStyle/>
-          <a:p>
-            <a:pPr marL="0" marR="0" lvl="0" indent="0" algn="l" defTabSz="914400" rtl="0" eaLnBrk="1" fontAlgn="auto" latinLnBrk="0" hangingPunct="1">
-              <a:lnSpc>
-                <a:spcPct val="100000"/>
-              </a:lnSpc>
-              <a:spcBef>
-                <a:spcPts val="0"/>
-              </a:spcBef>
-              <a:spcAft>
-                <a:spcPts val="0"/>
-              </a:spcAft>
-              <a:buClrTx/>
-              <a:buSzTx/>
-              <a:buFontTx/>
-              <a:buNone/>
-              <a:tabLst/>
-              <a:defRPr/>
-            </a:pPr>
-            <a:r>
-              <a:rPr kumimoji="0" lang="en-US" sz="1800" b="0" i="0" u="none" strike="noStrike" kern="1200" cap="none" spc="0" normalizeH="0" baseline="0" noProof="0" dirty="0" err="1">
-                <a:ln>
-                  <a:noFill/>
-                </a:ln>
-                <a:solidFill>
-                  <a:srgbClr val="000000"/>
-                </a:solidFill>
-                <a:effectLst/>
-                <a:uLnTx/>
-                <a:uFillTx/>
-                <a:latin typeface="Courier"/>
-                <a:ea typeface="+mn-ea"/>
-                <a:cs typeface="Courier"/>
-              </a:rPr>
-              <a:t>AudioInputStream</a:t>
-            </a:r>
-            <a:r>
-              <a:rPr kumimoji="0" lang="en-US" sz="1800" b="0" i="0" u="none" strike="noStrike" kern="1200" cap="none" spc="0" normalizeH="0" baseline="0" noProof="0" dirty="0">
-                <a:ln>
-                  <a:noFill/>
-                </a:ln>
-                <a:solidFill>
-                  <a:srgbClr val="000000"/>
-                </a:solidFill>
-                <a:effectLst/>
-                <a:uLnTx/>
-                <a:uFillTx/>
-                <a:latin typeface="Courier"/>
-                <a:ea typeface="+mn-ea"/>
-                <a:cs typeface="Courier"/>
-              </a:rPr>
-              <a:t> stream = </a:t>
-            </a:r>
-            <a:r>
-              <a:rPr kumimoji="0" lang="en-US" sz="1800" b="0" i="0" u="none" strike="noStrike" kern="1200" cap="none" spc="0" normalizeH="0" baseline="0" noProof="0" dirty="0" err="1">
-                <a:ln>
-                  <a:noFill/>
-                </a:ln>
-                <a:solidFill>
-                  <a:srgbClr val="000000"/>
-                </a:solidFill>
-                <a:effectLst/>
-                <a:uLnTx/>
-                <a:uFillTx/>
-                <a:latin typeface="Courier"/>
-                <a:ea typeface="+mn-ea"/>
-                <a:cs typeface="Courier"/>
-              </a:rPr>
-              <a:t>AudioSystem.getAudioInputStream(audioFile</a:t>
-            </a:r>
-            <a:r>
-              <a:rPr kumimoji="0" lang="en-US" sz="1800" b="0" i="0" u="none" strike="noStrike" kern="1200" cap="none" spc="0" normalizeH="0" baseline="0" noProof="0" dirty="0">
-                <a:ln>
-                  <a:noFill/>
-                </a:ln>
-                <a:solidFill>
-                  <a:srgbClr val="000000"/>
-                </a:solidFill>
-                <a:effectLst/>
-                <a:uLnTx/>
-                <a:uFillTx/>
-                <a:latin typeface="Courier"/>
-                <a:ea typeface="+mn-ea"/>
-                <a:cs typeface="Courier"/>
-              </a:rPr>
-              <a:t>);</a:t>
-            </a:r>
-          </a:p>
-        </p:txBody>
-      </p:sp>
-    </p:spTree>
-    <p:extLst>
-      <p:ext uri="{BB962C8B-B14F-4D97-AF65-F5344CB8AC3E}">
-        <p14:creationId xmlns:p14="http://schemas.microsoft.com/office/powerpoint/2010/main" val="227767069"/>
       </p:ext>
     </p:extLst>
   </p:cSld>
@@ -25224,6 +24655,697 @@
         </p:nvSpPr>
         <p:spPr>
           <a:xfrm>
+            <a:off x="936516" y="765946"/>
+            <a:ext cx="6176383" cy="747265"/>
+          </a:xfrm>
+        </p:spPr>
+        <p:txBody>
+          <a:bodyPr/>
+          <a:lstStyle/>
+          <a:p>
+            <a:r>
+              <a:rPr lang="en-US" dirty="0"/>
+              <a:t>Class </a:t>
+            </a:r>
+            <a:r>
+              <a:rPr lang="en-US" dirty="0" err="1">
+                <a:latin typeface="Courier"/>
+                <a:cs typeface="Courier"/>
+              </a:rPr>
+              <a:t>AudioInputStream</a:t>
+            </a:r>
+            <a:endParaRPr lang="en-US" dirty="0">
+              <a:latin typeface="Courier"/>
+              <a:cs typeface="Courier"/>
+            </a:endParaRPr>
+          </a:p>
+        </p:txBody>
+      </p:sp>
+      <p:sp>
+        <p:nvSpPr>
+          <p:cNvPr id="3" name="Content Placeholder 2"/>
+          <p:cNvSpPr>
+            <a:spLocks noGrp="1"/>
+          </p:cNvSpPr>
+          <p:nvPr>
+            <p:ph idx="1"/>
+          </p:nvPr>
+        </p:nvSpPr>
+        <p:spPr>
+          <a:xfrm>
+            <a:off x="936516" y="1907219"/>
+            <a:ext cx="10404472" cy="4724204"/>
+          </a:xfrm>
+        </p:spPr>
+        <p:txBody>
+          <a:bodyPr>
+            <a:normAutofit/>
+          </a:bodyPr>
+          <a:lstStyle/>
+          <a:p>
+            <a:r>
+              <a:rPr lang="en-US" dirty="0">
+                <a:solidFill>
+                  <a:schemeClr val="tx1"/>
+                </a:solidFill>
+              </a:rPr>
+              <a:t>To</a:t>
+            </a:r>
+            <a:r>
+              <a:rPr lang="en-US" dirty="0"/>
+              <a:t> </a:t>
+            </a:r>
+            <a:r>
+              <a:rPr lang="en-US" b="1" dirty="0">
+                <a:solidFill>
+                  <a:srgbClr val="0000FF"/>
+                </a:solidFill>
+              </a:rPr>
+              <a:t>read</a:t>
+            </a:r>
+            <a:r>
+              <a:rPr lang="en-US" dirty="0">
+                <a:solidFill>
+                  <a:srgbClr val="0000FF"/>
+                </a:solidFill>
+              </a:rPr>
+              <a:t> </a:t>
+            </a:r>
+            <a:r>
+              <a:rPr lang="en-US" dirty="0">
+                <a:solidFill>
+                  <a:schemeClr val="tx1"/>
+                </a:solidFill>
+              </a:rPr>
+              <a:t>an audio file, convert it to an </a:t>
+            </a:r>
+            <a:r>
+              <a:rPr lang="en-US" b="1" dirty="0">
+                <a:solidFill>
+                  <a:schemeClr val="tx1"/>
+                </a:solidFill>
+              </a:rPr>
+              <a:t>audio stream, </a:t>
+            </a:r>
+            <a:br>
+              <a:rPr lang="en-US" b="1" dirty="0">
+                <a:solidFill>
+                  <a:schemeClr val="tx1"/>
+                </a:solidFill>
+              </a:rPr>
+            </a:br>
+            <a:r>
+              <a:rPr lang="en-US" dirty="0">
+                <a:solidFill>
+                  <a:schemeClr val="tx1"/>
+                </a:solidFill>
+              </a:rPr>
+              <a:t>using</a:t>
+            </a:r>
+            <a:r>
+              <a:rPr lang="en-US" b="1" dirty="0">
+                <a:solidFill>
+                  <a:schemeClr val="tx1"/>
+                </a:solidFill>
+              </a:rPr>
+              <a:t> </a:t>
+            </a:r>
+            <a:r>
+              <a:rPr lang="en-US" dirty="0">
+                <a:solidFill>
+                  <a:schemeClr val="tx1"/>
+                </a:solidFill>
+              </a:rPr>
+              <a:t>the </a:t>
+            </a:r>
+            <a:r>
+              <a:rPr lang="en-US" sz="2000" dirty="0" err="1">
+                <a:solidFill>
+                  <a:schemeClr val="tx1"/>
+                </a:solidFill>
+                <a:latin typeface="Courier"/>
+                <a:cs typeface="Courier"/>
+              </a:rPr>
+              <a:t>getAudioInputStream</a:t>
+            </a:r>
+            <a:r>
+              <a:rPr lang="en-US" sz="2000" dirty="0">
+                <a:solidFill>
+                  <a:schemeClr val="tx1"/>
+                </a:solidFill>
+                <a:latin typeface="Courier"/>
+                <a:cs typeface="Courier"/>
+              </a:rPr>
+              <a:t>(…)</a:t>
+            </a:r>
+            <a:r>
+              <a:rPr lang="en-US" sz="2000" dirty="0">
+                <a:solidFill>
+                  <a:schemeClr val="tx1"/>
+                </a:solidFill>
+              </a:rPr>
+              <a:t> </a:t>
+            </a:r>
+            <a:r>
+              <a:rPr lang="en-US" dirty="0">
+                <a:solidFill>
+                  <a:schemeClr val="tx1"/>
+                </a:solidFill>
+              </a:rPr>
+              <a:t>method of </a:t>
+            </a:r>
+            <a:r>
+              <a:rPr lang="en-US" sz="2000" dirty="0" err="1">
+                <a:solidFill>
+                  <a:schemeClr val="tx1"/>
+                </a:solidFill>
+                <a:latin typeface="Courier"/>
+                <a:cs typeface="Courier"/>
+              </a:rPr>
+              <a:t>AudioSystem</a:t>
+            </a:r>
+            <a:r>
+              <a:rPr lang="en-US" dirty="0">
+                <a:solidFill>
+                  <a:schemeClr val="tx1"/>
+                </a:solidFill>
+              </a:rPr>
+              <a:t>:</a:t>
+            </a:r>
+          </a:p>
+          <a:p>
+            <a:endParaRPr lang="en-US" dirty="0">
+              <a:solidFill>
+                <a:schemeClr val="tx1"/>
+              </a:solidFill>
+            </a:endParaRPr>
+          </a:p>
+          <a:p>
+            <a:endParaRPr lang="en-US" dirty="0">
+              <a:solidFill>
+                <a:schemeClr val="tx1"/>
+              </a:solidFill>
+            </a:endParaRPr>
+          </a:p>
+          <a:p>
+            <a:r>
+              <a:rPr lang="en-US" dirty="0">
+                <a:solidFill>
+                  <a:schemeClr val="tx1"/>
+                </a:solidFill>
+              </a:rPr>
+              <a:t>To</a:t>
+            </a:r>
+            <a:r>
+              <a:rPr lang="en-US" dirty="0"/>
+              <a:t> </a:t>
+            </a:r>
+            <a:r>
+              <a:rPr lang="en-US" b="1" dirty="0">
+                <a:solidFill>
+                  <a:srgbClr val="0000FF"/>
+                </a:solidFill>
+              </a:rPr>
+              <a:t>open</a:t>
+            </a:r>
+            <a:r>
+              <a:rPr lang="en-US" dirty="0">
+                <a:solidFill>
+                  <a:srgbClr val="0000FF"/>
+                </a:solidFill>
+              </a:rPr>
+              <a:t> </a:t>
+            </a:r>
+            <a:r>
+              <a:rPr lang="en-US" dirty="0">
+                <a:solidFill>
+                  <a:schemeClr val="tx1"/>
+                </a:solidFill>
+              </a:rPr>
+              <a:t>an audio stream, use </a:t>
+            </a:r>
+            <a:r>
+              <a:rPr lang="en-US" sz="2000" dirty="0" err="1">
+                <a:solidFill>
+                  <a:schemeClr val="tx1"/>
+                </a:solidFill>
+                <a:latin typeface="Courier"/>
+                <a:cs typeface="Courier"/>
+              </a:rPr>
+              <a:t>AudioInputStream</a:t>
+            </a:r>
+            <a:r>
+              <a:rPr lang="en-US" sz="2000" dirty="0">
+                <a:solidFill>
+                  <a:schemeClr val="tx1"/>
+                </a:solidFill>
+                <a:cs typeface="Courier"/>
+              </a:rPr>
+              <a:t> </a:t>
+            </a:r>
+            <a:r>
+              <a:rPr lang="en-US" dirty="0">
+                <a:solidFill>
+                  <a:schemeClr val="tx1"/>
+                </a:solidFill>
+              </a:rPr>
+              <a:t>as argument.</a:t>
+            </a:r>
+          </a:p>
+          <a:p>
+            <a:endParaRPr lang="en-US" dirty="0">
+              <a:solidFill>
+                <a:schemeClr val="tx1"/>
+              </a:solidFill>
+            </a:endParaRPr>
+          </a:p>
+          <a:p>
+            <a:r>
+              <a:rPr lang="en-US" dirty="0">
+                <a:solidFill>
+                  <a:schemeClr val="tx1"/>
+                </a:solidFill>
+              </a:rPr>
+              <a:t>To </a:t>
+            </a:r>
+            <a:r>
+              <a:rPr lang="en-US" b="1" dirty="0">
+                <a:solidFill>
+                  <a:srgbClr val="0000FF"/>
+                </a:solidFill>
+              </a:rPr>
+              <a:t>start</a:t>
+            </a:r>
+            <a:r>
+              <a:rPr lang="en-US" dirty="0">
+                <a:solidFill>
+                  <a:srgbClr val="0000FF"/>
+                </a:solidFill>
+              </a:rPr>
+              <a:t> </a:t>
+            </a:r>
+            <a:r>
+              <a:rPr lang="en-US" dirty="0">
+                <a:solidFill>
+                  <a:schemeClr val="tx1"/>
+                </a:solidFill>
+              </a:rPr>
+              <a:t>playback, use </a:t>
+            </a:r>
+            <a:r>
+              <a:rPr lang="en-US" sz="2000" dirty="0">
+                <a:solidFill>
+                  <a:schemeClr val="tx1"/>
+                </a:solidFill>
+                <a:latin typeface="Courier"/>
+                <a:cs typeface="Courier"/>
+              </a:rPr>
+              <a:t>start</a:t>
+            </a:r>
+            <a:r>
+              <a:rPr lang="en-US" sz="2000" dirty="0">
+                <a:solidFill>
+                  <a:schemeClr val="tx1"/>
+                </a:solidFill>
+              </a:rPr>
+              <a:t> </a:t>
+            </a:r>
+            <a:r>
+              <a:rPr lang="en-US" dirty="0">
+                <a:solidFill>
+                  <a:schemeClr val="tx1"/>
+                </a:solidFill>
+              </a:rPr>
+              <a:t>method:</a:t>
+            </a:r>
+          </a:p>
+        </p:txBody>
+      </p:sp>
+      <p:sp>
+        <p:nvSpPr>
+          <p:cNvPr id="6" name="Rectangle 5"/>
+          <p:cNvSpPr/>
+          <p:nvPr/>
+        </p:nvSpPr>
+        <p:spPr>
+          <a:xfrm>
+            <a:off x="2486951" y="5148558"/>
+            <a:ext cx="6629400" cy="923330"/>
+          </a:xfrm>
+          <a:prstGeom prst="rect">
+            <a:avLst/>
+          </a:prstGeom>
+          <a:solidFill>
+            <a:srgbClr val="FFFFCC"/>
+          </a:solidFill>
+          <a:ln w="3175" cmpd="sng">
+            <a:solidFill>
+              <a:schemeClr val="tx1"/>
+            </a:solidFill>
+          </a:ln>
+        </p:spPr>
+        <p:txBody>
+          <a:bodyPr wrap="square">
+            <a:spAutoFit/>
+          </a:bodyPr>
+          <a:lstStyle/>
+          <a:p>
+            <a:pPr marL="0" marR="0" lvl="0" indent="0" algn="l" defTabSz="914400" rtl="0" eaLnBrk="1" fontAlgn="auto" latinLnBrk="0" hangingPunct="1">
+              <a:lnSpc>
+                <a:spcPct val="100000"/>
+              </a:lnSpc>
+              <a:spcBef>
+                <a:spcPts val="0"/>
+              </a:spcBef>
+              <a:spcAft>
+                <a:spcPts val="0"/>
+              </a:spcAft>
+              <a:buClrTx/>
+              <a:buSzTx/>
+              <a:buFontTx/>
+              <a:buNone/>
+              <a:tabLst/>
+              <a:defRPr/>
+            </a:pPr>
+            <a:r>
+              <a:rPr kumimoji="0" lang="en-US" sz="1800" b="0" i="0" u="none" strike="noStrike" kern="1200" cap="none" spc="0" normalizeH="0" baseline="0" noProof="0" dirty="0">
+                <a:ln>
+                  <a:noFill/>
+                </a:ln>
+                <a:solidFill>
+                  <a:srgbClr val="000000"/>
+                </a:solidFill>
+                <a:effectLst/>
+                <a:uLnTx/>
+                <a:uFillTx/>
+                <a:latin typeface="Courier"/>
+                <a:ea typeface="+mn-ea"/>
+                <a:cs typeface="Courier"/>
+              </a:rPr>
+              <a:t>Clip clip = (Clip) </a:t>
+            </a:r>
+            <a:r>
+              <a:rPr kumimoji="0" lang="en-US" sz="1800" b="0" i="0" u="none" strike="noStrike" kern="1200" cap="none" spc="0" normalizeH="0" baseline="0" noProof="0" dirty="0" err="1">
+                <a:ln>
+                  <a:noFill/>
+                </a:ln>
+                <a:solidFill>
+                  <a:srgbClr val="000000"/>
+                </a:solidFill>
+                <a:effectLst/>
+                <a:uLnTx/>
+                <a:uFillTx/>
+                <a:latin typeface="Courier"/>
+                <a:ea typeface="+mn-ea"/>
+                <a:cs typeface="Courier"/>
+              </a:rPr>
+              <a:t>AudioSystem.getClip</a:t>
+            </a:r>
+            <a:r>
+              <a:rPr kumimoji="0" lang="en-US" sz="1800" b="0" i="0" u="none" strike="noStrike" kern="1200" cap="none" spc="0" normalizeH="0" baseline="0" noProof="0" dirty="0">
+                <a:ln>
+                  <a:noFill/>
+                </a:ln>
+                <a:solidFill>
+                  <a:srgbClr val="000000"/>
+                </a:solidFill>
+                <a:effectLst/>
+                <a:uLnTx/>
+                <a:uFillTx/>
+                <a:latin typeface="Courier"/>
+                <a:ea typeface="+mn-ea"/>
+                <a:cs typeface="Courier"/>
+              </a:rPr>
+              <a:t>();</a:t>
+            </a:r>
+          </a:p>
+          <a:p>
+            <a:pPr marL="0" marR="0" lvl="0" indent="0" algn="l" defTabSz="914400" rtl="0" eaLnBrk="1" fontAlgn="auto" latinLnBrk="0" hangingPunct="1">
+              <a:lnSpc>
+                <a:spcPct val="100000"/>
+              </a:lnSpc>
+              <a:spcBef>
+                <a:spcPts val="0"/>
+              </a:spcBef>
+              <a:spcAft>
+                <a:spcPts val="0"/>
+              </a:spcAft>
+              <a:buClrTx/>
+              <a:buSzTx/>
+              <a:buFontTx/>
+              <a:buNone/>
+              <a:tabLst/>
+              <a:defRPr/>
+            </a:pPr>
+            <a:r>
+              <a:rPr kumimoji="0" lang="en-US" sz="1800" b="0" i="0" u="none" strike="noStrike" kern="1200" cap="none" spc="0" normalizeH="0" baseline="0" noProof="0" dirty="0" err="1">
+                <a:ln>
+                  <a:noFill/>
+                </a:ln>
+                <a:solidFill>
+                  <a:srgbClr val="000000"/>
+                </a:solidFill>
+                <a:effectLst/>
+                <a:uLnTx/>
+                <a:uFillTx/>
+                <a:latin typeface="Courier"/>
+                <a:ea typeface="+mn-ea"/>
+                <a:cs typeface="Courier"/>
+              </a:rPr>
+              <a:t>clip.open(stream</a:t>
+            </a:r>
+            <a:r>
+              <a:rPr kumimoji="0" lang="en-US" sz="1800" b="0" i="0" u="none" strike="noStrike" kern="1200" cap="none" spc="0" normalizeH="0" baseline="0" noProof="0" dirty="0">
+                <a:ln>
+                  <a:noFill/>
+                </a:ln>
+                <a:solidFill>
+                  <a:srgbClr val="000000"/>
+                </a:solidFill>
+                <a:effectLst/>
+                <a:uLnTx/>
+                <a:uFillTx/>
+                <a:latin typeface="Courier"/>
+                <a:ea typeface="+mn-ea"/>
+                <a:cs typeface="Courier"/>
+              </a:rPr>
+              <a:t>); 	// open the audio stream</a:t>
+            </a:r>
+          </a:p>
+          <a:p>
+            <a:pPr marL="0" marR="0" lvl="0" indent="0" algn="l" defTabSz="914400" rtl="0" eaLnBrk="1" fontAlgn="auto" latinLnBrk="0" hangingPunct="1">
+              <a:lnSpc>
+                <a:spcPct val="100000"/>
+              </a:lnSpc>
+              <a:spcBef>
+                <a:spcPts val="0"/>
+              </a:spcBef>
+              <a:spcAft>
+                <a:spcPts val="0"/>
+              </a:spcAft>
+              <a:buClrTx/>
+              <a:buSzTx/>
+              <a:buFontTx/>
+              <a:buNone/>
+              <a:tabLst/>
+              <a:defRPr/>
+            </a:pPr>
+            <a:r>
+              <a:rPr kumimoji="0" lang="en-US" sz="1800" b="0" i="0" u="none" strike="noStrike" kern="1200" cap="none" spc="0" normalizeH="0" baseline="0" noProof="0" dirty="0" err="1">
+                <a:ln>
+                  <a:noFill/>
+                </a:ln>
+                <a:solidFill>
+                  <a:srgbClr val="000000"/>
+                </a:solidFill>
+                <a:effectLst/>
+                <a:uLnTx/>
+                <a:uFillTx/>
+                <a:latin typeface="Courier"/>
+                <a:ea typeface="+mn-ea"/>
+                <a:cs typeface="Courier"/>
+              </a:rPr>
+              <a:t>clip.start</a:t>
+            </a:r>
+            <a:r>
+              <a:rPr kumimoji="0" lang="en-US" sz="1800" b="0" i="0" u="none" strike="noStrike" kern="1200" cap="none" spc="0" normalizeH="0" baseline="0" noProof="0" dirty="0">
+                <a:ln>
+                  <a:noFill/>
+                </a:ln>
+                <a:solidFill>
+                  <a:srgbClr val="000000"/>
+                </a:solidFill>
+                <a:effectLst/>
+                <a:uLnTx/>
+                <a:uFillTx/>
+                <a:latin typeface="Courier"/>
+                <a:ea typeface="+mn-ea"/>
+                <a:cs typeface="Courier"/>
+              </a:rPr>
+              <a:t>(); 	// start playing the audio</a:t>
+            </a:r>
+          </a:p>
+        </p:txBody>
+      </p:sp>
+      <p:sp>
+        <p:nvSpPr>
+          <p:cNvPr id="7" name="Rectangle 6"/>
+          <p:cNvSpPr/>
+          <p:nvPr/>
+        </p:nvSpPr>
+        <p:spPr>
+          <a:xfrm>
+            <a:off x="1212455" y="2911469"/>
+            <a:ext cx="9655147" cy="369332"/>
+          </a:xfrm>
+          <a:prstGeom prst="rect">
+            <a:avLst/>
+          </a:prstGeom>
+          <a:solidFill>
+            <a:srgbClr val="FFFFCC"/>
+          </a:solidFill>
+          <a:ln w="3175" cmpd="sng">
+            <a:solidFill>
+              <a:schemeClr val="tx1"/>
+            </a:solidFill>
+          </a:ln>
+        </p:spPr>
+        <p:txBody>
+          <a:bodyPr wrap="square">
+            <a:spAutoFit/>
+          </a:bodyPr>
+          <a:lstStyle/>
+          <a:p>
+            <a:pPr marL="0" marR="0" lvl="0" indent="0" algn="l" defTabSz="914400" rtl="0" eaLnBrk="1" fontAlgn="auto" latinLnBrk="0" hangingPunct="1">
+              <a:lnSpc>
+                <a:spcPct val="100000"/>
+              </a:lnSpc>
+              <a:spcBef>
+                <a:spcPts val="0"/>
+              </a:spcBef>
+              <a:spcAft>
+                <a:spcPts val="0"/>
+              </a:spcAft>
+              <a:buClrTx/>
+              <a:buSzTx/>
+              <a:buFontTx/>
+              <a:buNone/>
+              <a:tabLst/>
+              <a:defRPr/>
+            </a:pPr>
+            <a:r>
+              <a:rPr kumimoji="0" lang="en-US" sz="1800" b="0" i="0" u="none" strike="noStrike" kern="1200" cap="none" spc="0" normalizeH="0" baseline="0" noProof="0" dirty="0" err="1">
+                <a:ln>
+                  <a:noFill/>
+                </a:ln>
+                <a:solidFill>
+                  <a:srgbClr val="000000"/>
+                </a:solidFill>
+                <a:effectLst/>
+                <a:uLnTx/>
+                <a:uFillTx/>
+                <a:latin typeface="Courier"/>
+                <a:ea typeface="+mn-ea"/>
+                <a:cs typeface="Courier"/>
+              </a:rPr>
+              <a:t>AudioInputStream</a:t>
+            </a:r>
+            <a:r>
+              <a:rPr kumimoji="0" lang="en-US" sz="1800" b="0" i="0" u="none" strike="noStrike" kern="1200" cap="none" spc="0" normalizeH="0" baseline="0" noProof="0" dirty="0">
+                <a:ln>
+                  <a:noFill/>
+                </a:ln>
+                <a:solidFill>
+                  <a:srgbClr val="000000"/>
+                </a:solidFill>
+                <a:effectLst/>
+                <a:uLnTx/>
+                <a:uFillTx/>
+                <a:latin typeface="Courier"/>
+                <a:ea typeface="+mn-ea"/>
+                <a:cs typeface="Courier"/>
+              </a:rPr>
+              <a:t> stream = </a:t>
+            </a:r>
+            <a:r>
+              <a:rPr kumimoji="0" lang="en-US" sz="1800" b="0" i="0" u="none" strike="noStrike" kern="1200" cap="none" spc="0" normalizeH="0" baseline="0" noProof="0" dirty="0" err="1">
+                <a:ln>
+                  <a:noFill/>
+                </a:ln>
+                <a:solidFill>
+                  <a:srgbClr val="000000"/>
+                </a:solidFill>
+                <a:effectLst/>
+                <a:uLnTx/>
+                <a:uFillTx/>
+                <a:latin typeface="Courier"/>
+                <a:ea typeface="+mn-ea"/>
+                <a:cs typeface="Courier"/>
+              </a:rPr>
+              <a:t>AudioSystem.getAudioInputStream(audioFile</a:t>
+            </a:r>
+            <a:r>
+              <a:rPr kumimoji="0" lang="en-US" sz="1800" b="0" i="0" u="none" strike="noStrike" kern="1200" cap="none" spc="0" normalizeH="0" baseline="0" noProof="0" dirty="0">
+                <a:ln>
+                  <a:noFill/>
+                </a:ln>
+                <a:solidFill>
+                  <a:srgbClr val="000000"/>
+                </a:solidFill>
+                <a:effectLst/>
+                <a:uLnTx/>
+                <a:uFillTx/>
+                <a:latin typeface="Courier"/>
+                <a:ea typeface="+mn-ea"/>
+                <a:cs typeface="Courier"/>
+              </a:rPr>
+              <a:t>);</a:t>
+            </a:r>
+          </a:p>
+        </p:txBody>
+      </p:sp>
+    </p:spTree>
+    <p:extLst>
+      <p:ext uri="{BB962C8B-B14F-4D97-AF65-F5344CB8AC3E}">
+        <p14:creationId xmlns:p14="http://schemas.microsoft.com/office/powerpoint/2010/main" val="227767069"/>
+      </p:ext>
+    </p:extLst>
+  </p:cSld>
+  <p:clrMapOvr>
+    <a:masterClrMapping/>
+  </p:clrMapOvr>
+</p:sld>
+</file>
+
+<file path=ppt/slides/slide71.xml><?xml version="1.0" encoding="utf-8"?>
+<p:sld xmlns:a="http://schemas.openxmlformats.org/drawingml/2006/main" xmlns:r="http://schemas.openxmlformats.org/officeDocument/2006/relationships" xmlns:p="http://schemas.openxmlformats.org/presentationml/2006/main">
+  <p:cSld>
+    <p:spTree>
+      <p:nvGrpSpPr>
+        <p:cNvPr id="1" name=""/>
+        <p:cNvGrpSpPr/>
+        <p:nvPr/>
+      </p:nvGrpSpPr>
+      <p:grpSpPr>
+        <a:xfrm>
+          <a:off x="0" y="0"/>
+          <a:ext cx="0" cy="0"/>
+          <a:chOff x="0" y="0"/>
+          <a:chExt cx="0" cy="0"/>
+        </a:xfrm>
+      </p:grpSpPr>
+      <p:sp>
+        <p:nvSpPr>
+          <p:cNvPr id="2" name="Title 1"/>
+          <p:cNvSpPr>
+            <a:spLocks noGrp="1"/>
+          </p:cNvSpPr>
+          <p:nvPr>
+            <p:ph type="title"/>
+          </p:nvPr>
+        </p:nvSpPr>
+        <p:spPr>
+          <a:xfrm>
             <a:off x="936516" y="749512"/>
             <a:ext cx="6621445" cy="743470"/>
           </a:xfrm>
@@ -25530,7 +25652,7 @@
 </p:sld>
 </file>
 
-<file path=ppt/slides/slide71.xml><?xml version="1.0" encoding="utf-8"?>
+<file path=ppt/slides/slide72.xml><?xml version="1.0" encoding="utf-8"?>
 <p:sld xmlns:a="http://schemas.openxmlformats.org/drawingml/2006/main" xmlns:r="http://schemas.openxmlformats.org/officeDocument/2006/relationships" xmlns:p="http://schemas.openxmlformats.org/presentationml/2006/main">
   <p:cSld>
     <p:spTree>
@@ -25859,7 +25981,7 @@
 </p:sld>
 </file>
 
-<file path=ppt/slides/slide72.xml><?xml version="1.0" encoding="utf-8"?>
+<file path=ppt/slides/slide73.xml><?xml version="1.0" encoding="utf-8"?>
 <p:sld xmlns:a="http://schemas.openxmlformats.org/drawingml/2006/main" xmlns:r="http://schemas.openxmlformats.org/officeDocument/2006/relationships" xmlns:p="http://schemas.openxmlformats.org/presentationml/2006/main">
   <p:cSld>
     <p:spTree>
@@ -26164,23 +26286,8 @@
             </a:lvl9pPr>
           </a:lstStyle>
           <a:p>
-            <a:pPr marL="0" marR="0" lvl="0" indent="0" algn="ctr" defTabSz="914400" rtl="0" eaLnBrk="1" fontAlgn="auto" latinLnBrk="0" hangingPunct="1">
-              <a:lnSpc>
-                <a:spcPct val="90000"/>
-              </a:lnSpc>
-              <a:spcBef>
-                <a:spcPts val="1000"/>
-              </a:spcBef>
-              <a:spcAft>
-                <a:spcPts val="0"/>
-              </a:spcAft>
-              <a:buClr>
-                <a:srgbClr val="B30738"/>
-              </a:buClr>
-              <a:buSzTx/>
-              <a:buFont typeface="Arial" panose="020B0604020202020204" pitchFamily="34" charset="0"/>
-              <a:buNone/>
-              <a:tabLst/>
+            <a:pPr marL="0" indent="0" algn="ctr">
+              <a:buNone/>
               <a:defRPr/>
             </a:pPr>
             <a:r>
@@ -26197,8 +26304,29 @@
                 <a:latin typeface="Arial" panose="020B0604020202020204"/>
                 <a:ea typeface="+mn-ea"/>
               </a:rPr>
-              <a:t>“CSEN160_06_Lecture_FileIO_AdvancedFileIO_Serialize.scu.csen160.AudioPlayer.play(…)”</a:t>
-            </a:r>
+              <a:t>CSEN160_06_Lecture_FileIO_AdvancedFileIO_Serialize.scu.csen160.AudioExample.</a:t>
+            </a:r>
+            <a:r>
+              <a:rPr lang="en-US" dirty="0" err="1">
+                <a:solidFill>
+                  <a:srgbClr val="FF0000"/>
+                </a:solidFill>
+              </a:rPr>
+              <a:t>B_PlayAudio</a:t>
+            </a:r>
+            <a:endParaRPr kumimoji="0" lang="en-US" sz="2600" b="0" i="0" u="none" strike="noStrike" kern="1200" cap="none" spc="0" normalizeH="0" baseline="0" noProof="0" dirty="0">
+              <a:ln>
+                <a:noFill/>
+              </a:ln>
+              <a:solidFill>
+                <a:srgbClr val="FF0000"/>
+              </a:solidFill>
+              <a:effectLst/>
+              <a:uLnTx/>
+              <a:uFillTx/>
+              <a:latin typeface="Arial" panose="020B0604020202020204"/>
+              <a:ea typeface="+mn-ea"/>
+            </a:endParaRPr>
           </a:p>
         </p:txBody>
       </p:sp>
@@ -26215,7 +26343,7 @@
 </p:sld>
 </file>
 
-<file path=ppt/slides/slide73.xml><?xml version="1.0" encoding="utf-8"?>
+<file path=ppt/slides/slide74.xml><?xml version="1.0" encoding="utf-8"?>
 <p:sld xmlns:a="http://schemas.openxmlformats.org/drawingml/2006/main" xmlns:r="http://schemas.openxmlformats.org/officeDocument/2006/relationships" xmlns:p="http://schemas.openxmlformats.org/presentationml/2006/main">
   <p:cSld>
     <p:spTree>
@@ -26284,7 +26412,7 @@
 </p:sld>
 </file>
 
-<file path=ppt/slides/slide74.xml><?xml version="1.0" encoding="utf-8"?>
+<file path=ppt/slides/slide75.xml><?xml version="1.0" encoding="utf-8"?>
 <p:sld xmlns:a="http://schemas.openxmlformats.org/drawingml/2006/main" xmlns:r="http://schemas.openxmlformats.org/officeDocument/2006/relationships" xmlns:p="http://schemas.openxmlformats.org/presentationml/2006/main">
   <p:cSld>
     <p:spTree>
@@ -26731,7 +26859,7 @@
 </p:sld>
 </file>
 
-<file path=ppt/slides/slide75.xml><?xml version="1.0" encoding="utf-8"?>
+<file path=ppt/slides/slide76.xml><?xml version="1.0" encoding="utf-8"?>
 <p:sld xmlns:a="http://schemas.openxmlformats.org/drawingml/2006/main" xmlns:r="http://schemas.openxmlformats.org/officeDocument/2006/relationships" xmlns:p="http://schemas.openxmlformats.org/presentationml/2006/main">
   <p:cSld>
     <p:spTree>
@@ -27011,6 +27139,41 @@
             </a:lvl9pPr>
           </a:lstStyle>
           <a:p>
+            <a:pPr marL="0" indent="0" algn="ctr">
+              <a:buNone/>
+              <a:defRPr/>
+            </a:pPr>
+            <a:r>
+              <a:rPr kumimoji="0" lang="en-US" sz="2600" b="0" i="0" u="none" strike="noStrike" kern="1200" cap="none" spc="0" normalizeH="0" baseline="0" noProof="0" dirty="0">
+                <a:ln>
+                  <a:noFill/>
+                </a:ln>
+                <a:solidFill>
+                  <a:srgbClr val="FF0000"/>
+                </a:solidFill>
+                <a:effectLst/>
+                <a:uLnTx/>
+                <a:uFillTx/>
+                <a:latin typeface="Arial" panose="020B0604020202020204"/>
+                <a:ea typeface="+mn-ea"/>
+              </a:rPr>
+              <a:t>CSEN160_06_Lecture_FileIO_AdvancedFileIO_Serialize.scu.csen160.AudioExample.</a:t>
+            </a:r>
+            <a:r>
+              <a:rPr lang="en-US" dirty="0" err="1">
+                <a:solidFill>
+                  <a:srgbClr val="FF0000"/>
+                </a:solidFill>
+              </a:rPr>
+              <a:t>C_AudioMerge</a:t>
+            </a:r>
+            <a:endParaRPr lang="en-US" dirty="0">
+              <a:solidFill>
+                <a:srgbClr val="FF0000"/>
+              </a:solidFill>
+            </a:endParaRPr>
+          </a:p>
+          <a:p>
             <a:pPr marL="0" marR="0" lvl="0" indent="0" algn="ctr" defTabSz="914400" rtl="0" eaLnBrk="1" fontAlgn="auto" latinLnBrk="0" hangingPunct="1">
               <a:lnSpc>
                 <a:spcPct val="90000"/>
@@ -27030,22 +27193,19 @@
               <a:tabLst/>
               <a:defRPr/>
             </a:pPr>
-            <a:r>
-              <a:rPr kumimoji="0" lang="en-US" sz="2600" b="0" i="0" u="none" strike="noStrike" kern="1200" cap="none" spc="0" normalizeH="0" baseline="0" noProof="0" dirty="0">
-                <a:ln>
-                  <a:noFill/>
-                </a:ln>
-                <a:solidFill>
-                  <a:srgbClr val="FF0000"/>
-                </a:solidFill>
-                <a:effectLst/>
-                <a:uLnTx/>
-                <a:uFillTx/>
-                <a:latin typeface="Arial" panose="020B0604020202020204"/>
-                <a:ea typeface="+mn-ea"/>
-              </a:rPr>
-              <a:t>“CSEN160_06_Lecture_FileIO_AdvancedFileIO_Serialize.scu.csen160.E_AudioMixer.merge(…)”</a:t>
-            </a:r>
+            <a:endParaRPr kumimoji="0" lang="en-US" sz="2600" b="0" i="0" u="none" strike="noStrike" kern="1200" cap="none" spc="0" normalizeH="0" baseline="0" noProof="0" dirty="0">
+              <a:ln>
+                <a:noFill/>
+              </a:ln>
+              <a:solidFill>
+                <a:srgbClr val="FF0000"/>
+              </a:solidFill>
+              <a:effectLst/>
+              <a:uLnTx/>
+              <a:uFillTx/>
+              <a:latin typeface="Arial" panose="020B0604020202020204"/>
+              <a:ea typeface="+mn-ea"/>
+            </a:endParaRPr>
           </a:p>
         </p:txBody>
       </p:sp>
@@ -27092,7 +27252,7 @@
 </p:sld>
 </file>
 
-<file path=ppt/slides/slide76.xml><?xml version="1.0" encoding="utf-8"?>
+<file path=ppt/slides/slide77.xml><?xml version="1.0" encoding="utf-8"?>
 <p:sld xmlns:a="http://schemas.openxmlformats.org/drawingml/2006/main" xmlns:r="http://schemas.openxmlformats.org/officeDocument/2006/relationships" xmlns:p="http://schemas.openxmlformats.org/presentationml/2006/main">
   <p:cSld>
     <p:spTree>
@@ -27140,204 +27300,6 @@
     <p:extLst>
       <p:ext uri="{BB962C8B-B14F-4D97-AF65-F5344CB8AC3E}">
         <p14:creationId xmlns:p14="http://schemas.microsoft.com/office/powerpoint/2010/main" val="1361112149"/>
-      </p:ext>
-    </p:extLst>
-  </p:cSld>
-  <p:clrMapOvr>
-    <a:masterClrMapping/>
-  </p:clrMapOvr>
-</p:sld>
-</file>
-
-<file path=ppt/slides/slide77.xml><?xml version="1.0" encoding="utf-8"?>
-<p:sld xmlns:a="http://schemas.openxmlformats.org/drawingml/2006/main" xmlns:r="http://schemas.openxmlformats.org/officeDocument/2006/relationships" xmlns:p="http://schemas.openxmlformats.org/presentationml/2006/main">
-  <p:cSld>
-    <p:spTree>
-      <p:nvGrpSpPr>
-        <p:cNvPr id="1" name=""/>
-        <p:cNvGrpSpPr/>
-        <p:nvPr/>
-      </p:nvGrpSpPr>
-      <p:grpSpPr>
-        <a:xfrm>
-          <a:off x="0" y="0"/>
-          <a:ext cx="0" cy="0"/>
-          <a:chOff x="0" y="0"/>
-          <a:chExt cx="0" cy="0"/>
-        </a:xfrm>
-      </p:grpSpPr>
-      <p:sp>
-        <p:nvSpPr>
-          <p:cNvPr id="2" name="Title 1"/>
-          <p:cNvSpPr>
-            <a:spLocks noGrp="1"/>
-          </p:cNvSpPr>
-          <p:nvPr>
-            <p:ph type="title"/>
-          </p:nvPr>
-        </p:nvSpPr>
-        <p:spPr>
-          <a:xfrm>
-            <a:off x="936516" y="769741"/>
-            <a:ext cx="3089272" cy="662549"/>
-          </a:xfrm>
-        </p:spPr>
-        <p:txBody>
-          <a:bodyPr/>
-          <a:lstStyle/>
-          <a:p>
-            <a:r>
-              <a:rPr lang="en-US" dirty="0"/>
-              <a:t>Serialization</a:t>
-            </a:r>
-          </a:p>
-        </p:txBody>
-      </p:sp>
-      <p:sp>
-        <p:nvSpPr>
-          <p:cNvPr id="3" name="Content Placeholder 2"/>
-          <p:cNvSpPr>
-            <a:spLocks noGrp="1"/>
-          </p:cNvSpPr>
-          <p:nvPr>
-            <p:ph idx="1"/>
-          </p:nvPr>
-        </p:nvSpPr>
-        <p:spPr>
-          <a:xfrm>
-            <a:off x="936516" y="1907219"/>
-            <a:ext cx="10368057" cy="4748480"/>
-          </a:xfrm>
-        </p:spPr>
-        <p:txBody>
-          <a:bodyPr/>
-          <a:lstStyle/>
-          <a:p>
-            <a:pPr marL="0" indent="0">
-              <a:buNone/>
-            </a:pPr>
-            <a:r>
-              <a:rPr lang="en-US" b="1" dirty="0">
-                <a:solidFill>
-                  <a:schemeClr val="tx1"/>
-                </a:solidFill>
-              </a:rPr>
-              <a:t>Serialization: </a:t>
-            </a:r>
-            <a:r>
-              <a:rPr lang="en-US" dirty="0">
-                <a:solidFill>
-                  <a:schemeClr val="tx1"/>
-                </a:solidFill>
-              </a:rPr>
-              <a:t>saving an object to disk:</a:t>
-            </a:r>
-          </a:p>
-          <a:p>
-            <a:endParaRPr lang="en-US" dirty="0">
-              <a:solidFill>
-                <a:schemeClr val="tx1"/>
-              </a:solidFill>
-            </a:endParaRPr>
-          </a:p>
-          <a:p>
-            <a:r>
-              <a:rPr lang="en-US" dirty="0">
-                <a:solidFill>
-                  <a:schemeClr val="tx1"/>
-                </a:solidFill>
-              </a:rPr>
-              <a:t>When an object is serialized: it is </a:t>
-            </a:r>
-            <a:r>
-              <a:rPr lang="en-US" b="1" dirty="0">
-                <a:solidFill>
-                  <a:schemeClr val="tx1"/>
-                </a:solidFill>
-              </a:rPr>
-              <a:t>flattened/deflated. </a:t>
-            </a:r>
-          </a:p>
-          <a:p>
-            <a:endParaRPr lang="en-US" dirty="0">
-              <a:solidFill>
-                <a:schemeClr val="tx1"/>
-              </a:solidFill>
-            </a:endParaRPr>
-          </a:p>
-          <a:p>
-            <a:r>
-              <a:rPr lang="en-US" dirty="0">
-                <a:solidFill>
-                  <a:schemeClr val="tx1"/>
-                </a:solidFill>
-              </a:rPr>
-              <a:t>The reverse of constructing an object back from the binary data is </a:t>
-            </a:r>
-            <a:r>
-              <a:rPr lang="en-US" b="1" dirty="0">
-                <a:solidFill>
-                  <a:schemeClr val="tx1"/>
-                </a:solidFill>
-              </a:rPr>
-              <a:t>deserialization. </a:t>
-            </a:r>
-          </a:p>
-          <a:p>
-            <a:endParaRPr lang="en-US" dirty="0">
-              <a:solidFill>
-                <a:schemeClr val="tx1"/>
-              </a:solidFill>
-            </a:endParaRPr>
-          </a:p>
-          <a:p>
-            <a:r>
-              <a:rPr lang="en-US" dirty="0">
-                <a:solidFill>
-                  <a:schemeClr val="tx1"/>
-                </a:solidFill>
-              </a:rPr>
-              <a:t>A </a:t>
-            </a:r>
-            <a:r>
-              <a:rPr lang="en-US" b="1" dirty="0">
-                <a:solidFill>
-                  <a:schemeClr val="tx1"/>
-                </a:solidFill>
-              </a:rPr>
-              <a:t>deserialized (or inflated) </a:t>
-            </a:r>
-            <a:r>
-              <a:rPr lang="en-US" dirty="0">
-                <a:solidFill>
-                  <a:schemeClr val="tx1"/>
-                </a:solidFill>
-              </a:rPr>
-              <a:t>object is one </a:t>
-            </a:r>
-            <a:r>
-              <a:rPr lang="en-US" b="1" dirty="0">
-                <a:solidFill>
-                  <a:schemeClr val="tx1"/>
-                </a:solidFill>
-              </a:rPr>
-              <a:t>whose state has been restored</a:t>
-            </a:r>
-            <a:r>
-              <a:rPr lang="en-US" dirty="0">
-                <a:solidFill>
-                  <a:schemeClr val="tx1"/>
-                </a:solidFill>
-              </a:rPr>
-              <a:t>.</a:t>
-            </a:r>
-          </a:p>
-        </p:txBody>
-      </p:sp>
-    </p:spTree>
-    <p:extLst>
-      <p:ext uri="{BB962C8B-B14F-4D97-AF65-F5344CB8AC3E}">
-        <p14:creationId xmlns:p14="http://schemas.microsoft.com/office/powerpoint/2010/main" val="2094830173"/>
       </p:ext>
     </p:extLst>
   </p:cSld>
@@ -27376,6 +27338,204 @@
         </p:nvSpPr>
         <p:spPr>
           <a:xfrm>
+            <a:off x="936516" y="769741"/>
+            <a:ext cx="3089272" cy="662549"/>
+          </a:xfrm>
+        </p:spPr>
+        <p:txBody>
+          <a:bodyPr/>
+          <a:lstStyle/>
+          <a:p>
+            <a:r>
+              <a:rPr lang="en-US" dirty="0"/>
+              <a:t>Serialization</a:t>
+            </a:r>
+          </a:p>
+        </p:txBody>
+      </p:sp>
+      <p:sp>
+        <p:nvSpPr>
+          <p:cNvPr id="3" name="Content Placeholder 2"/>
+          <p:cNvSpPr>
+            <a:spLocks noGrp="1"/>
+          </p:cNvSpPr>
+          <p:nvPr>
+            <p:ph idx="1"/>
+          </p:nvPr>
+        </p:nvSpPr>
+        <p:spPr>
+          <a:xfrm>
+            <a:off x="936516" y="1907219"/>
+            <a:ext cx="10368057" cy="4748480"/>
+          </a:xfrm>
+        </p:spPr>
+        <p:txBody>
+          <a:bodyPr/>
+          <a:lstStyle/>
+          <a:p>
+            <a:pPr marL="0" indent="0">
+              <a:buNone/>
+            </a:pPr>
+            <a:r>
+              <a:rPr lang="en-US" b="1" dirty="0">
+                <a:solidFill>
+                  <a:schemeClr val="tx1"/>
+                </a:solidFill>
+              </a:rPr>
+              <a:t>Serialization: </a:t>
+            </a:r>
+            <a:r>
+              <a:rPr lang="en-US" dirty="0">
+                <a:solidFill>
+                  <a:schemeClr val="tx1"/>
+                </a:solidFill>
+              </a:rPr>
+              <a:t>saving an object to disk:</a:t>
+            </a:r>
+          </a:p>
+          <a:p>
+            <a:endParaRPr lang="en-US" dirty="0">
+              <a:solidFill>
+                <a:schemeClr val="tx1"/>
+              </a:solidFill>
+            </a:endParaRPr>
+          </a:p>
+          <a:p>
+            <a:r>
+              <a:rPr lang="en-US" dirty="0">
+                <a:solidFill>
+                  <a:schemeClr val="tx1"/>
+                </a:solidFill>
+              </a:rPr>
+              <a:t>When an object is serialized: it is </a:t>
+            </a:r>
+            <a:r>
+              <a:rPr lang="en-US" b="1" dirty="0">
+                <a:solidFill>
+                  <a:schemeClr val="tx1"/>
+                </a:solidFill>
+              </a:rPr>
+              <a:t>flattened/deflated. </a:t>
+            </a:r>
+          </a:p>
+          <a:p>
+            <a:endParaRPr lang="en-US" dirty="0">
+              <a:solidFill>
+                <a:schemeClr val="tx1"/>
+              </a:solidFill>
+            </a:endParaRPr>
+          </a:p>
+          <a:p>
+            <a:r>
+              <a:rPr lang="en-US" dirty="0">
+                <a:solidFill>
+                  <a:schemeClr val="tx1"/>
+                </a:solidFill>
+              </a:rPr>
+              <a:t>The reverse of constructing an object back from the binary data is </a:t>
+            </a:r>
+            <a:r>
+              <a:rPr lang="en-US" b="1" dirty="0">
+                <a:solidFill>
+                  <a:schemeClr val="tx1"/>
+                </a:solidFill>
+              </a:rPr>
+              <a:t>deserialization. </a:t>
+            </a:r>
+          </a:p>
+          <a:p>
+            <a:endParaRPr lang="en-US" dirty="0">
+              <a:solidFill>
+                <a:schemeClr val="tx1"/>
+              </a:solidFill>
+            </a:endParaRPr>
+          </a:p>
+          <a:p>
+            <a:r>
+              <a:rPr lang="en-US" dirty="0">
+                <a:solidFill>
+                  <a:schemeClr val="tx1"/>
+                </a:solidFill>
+              </a:rPr>
+              <a:t>A </a:t>
+            </a:r>
+            <a:r>
+              <a:rPr lang="en-US" b="1" dirty="0">
+                <a:solidFill>
+                  <a:schemeClr val="tx1"/>
+                </a:solidFill>
+              </a:rPr>
+              <a:t>deserialized (or inflated) </a:t>
+            </a:r>
+            <a:r>
+              <a:rPr lang="en-US" dirty="0">
+                <a:solidFill>
+                  <a:schemeClr val="tx1"/>
+                </a:solidFill>
+              </a:rPr>
+              <a:t>object is one </a:t>
+            </a:r>
+            <a:r>
+              <a:rPr lang="en-US" b="1" dirty="0">
+                <a:solidFill>
+                  <a:schemeClr val="tx1"/>
+                </a:solidFill>
+              </a:rPr>
+              <a:t>whose state has been restored</a:t>
+            </a:r>
+            <a:r>
+              <a:rPr lang="en-US" dirty="0">
+                <a:solidFill>
+                  <a:schemeClr val="tx1"/>
+                </a:solidFill>
+              </a:rPr>
+              <a:t>.</a:t>
+            </a:r>
+          </a:p>
+        </p:txBody>
+      </p:sp>
+    </p:spTree>
+    <p:extLst>
+      <p:ext uri="{BB962C8B-B14F-4D97-AF65-F5344CB8AC3E}">
+        <p14:creationId xmlns:p14="http://schemas.microsoft.com/office/powerpoint/2010/main" val="2094830173"/>
+      </p:ext>
+    </p:extLst>
+  </p:cSld>
+  <p:clrMapOvr>
+    <a:masterClrMapping/>
+  </p:clrMapOvr>
+</p:sld>
+</file>
+
+<file path=ppt/slides/slide79.xml><?xml version="1.0" encoding="utf-8"?>
+<p:sld xmlns:a="http://schemas.openxmlformats.org/drawingml/2006/main" xmlns:r="http://schemas.openxmlformats.org/officeDocument/2006/relationships" xmlns:p="http://schemas.openxmlformats.org/presentationml/2006/main">
+  <p:cSld>
+    <p:spTree>
+      <p:nvGrpSpPr>
+        <p:cNvPr id="1" name=""/>
+        <p:cNvGrpSpPr/>
+        <p:nvPr/>
+      </p:nvGrpSpPr>
+      <p:grpSpPr>
+        <a:xfrm>
+          <a:off x="0" y="0"/>
+          <a:ext cx="0" cy="0"/>
+          <a:chOff x="0" y="0"/>
+          <a:chExt cx="0" cy="0"/>
+        </a:xfrm>
+      </p:grpSpPr>
+      <p:sp>
+        <p:nvSpPr>
+          <p:cNvPr id="2" name="Title 1"/>
+          <p:cNvSpPr>
+            <a:spLocks noGrp="1"/>
+          </p:cNvSpPr>
+          <p:nvPr>
+            <p:ph type="title"/>
+          </p:nvPr>
+        </p:nvSpPr>
+        <p:spPr>
+          <a:xfrm>
             <a:off x="936516" y="789971"/>
             <a:ext cx="10417284" cy="654457"/>
           </a:xfrm>
@@ -27642,7 +27802,633 @@
 </p:sld>
 </file>
 
-<file path=ppt/slides/slide79.xml><?xml version="1.0" encoding="utf-8"?>
+<file path=ppt/slides/slide8.xml><?xml version="1.0" encoding="utf-8"?>
+<p:sld xmlns:a="http://schemas.openxmlformats.org/drawingml/2006/main" xmlns:r="http://schemas.openxmlformats.org/officeDocument/2006/relationships" xmlns:p="http://schemas.openxmlformats.org/presentationml/2006/main">
+  <p:cSld>
+    <p:spTree>
+      <p:nvGrpSpPr>
+        <p:cNvPr id="1" name=""/>
+        <p:cNvGrpSpPr/>
+        <p:nvPr/>
+      </p:nvGrpSpPr>
+      <p:grpSpPr>
+        <a:xfrm>
+          <a:off x="0" y="0"/>
+          <a:ext cx="0" cy="0"/>
+          <a:chOff x="0" y="0"/>
+          <a:chExt cx="0" cy="0"/>
+        </a:xfrm>
+      </p:grpSpPr>
+      <p:sp>
+        <p:nvSpPr>
+          <p:cNvPr id="2" name="Title 1"/>
+          <p:cNvSpPr>
+            <a:spLocks noGrp="1"/>
+          </p:cNvSpPr>
+          <p:nvPr>
+            <p:ph type="title"/>
+          </p:nvPr>
+        </p:nvSpPr>
+        <p:spPr>
+          <a:xfrm>
+            <a:off x="936516" y="749511"/>
+            <a:ext cx="3987488" cy="662549"/>
+          </a:xfrm>
+        </p:spPr>
+        <p:txBody>
+          <a:bodyPr>
+            <a:normAutofit/>
+          </a:bodyPr>
+          <a:lstStyle/>
+          <a:p>
+            <a:r>
+              <a:rPr lang="en-US" dirty="0"/>
+              <a:t>IntelliJ example</a:t>
+            </a:r>
+          </a:p>
+        </p:txBody>
+      </p:sp>
+      <p:sp>
+        <p:nvSpPr>
+          <p:cNvPr id="3" name="Content Placeholder 2"/>
+          <p:cNvSpPr>
+            <a:spLocks noGrp="1"/>
+          </p:cNvSpPr>
+          <p:nvPr>
+            <p:ph idx="1"/>
+          </p:nvPr>
+        </p:nvSpPr>
+        <p:spPr>
+          <a:xfrm>
+            <a:off x="936516" y="1822253"/>
+            <a:ext cx="10388288" cy="4809170"/>
+          </a:xfrm>
+        </p:spPr>
+        <p:txBody>
+          <a:bodyPr/>
+          <a:lstStyle/>
+          <a:p>
+            <a:pPr marL="0" indent="0">
+              <a:buNone/>
+            </a:pPr>
+            <a:r>
+              <a:rPr lang="en-US" dirty="0">
+                <a:solidFill>
+                  <a:schemeClr val="tx1"/>
+                </a:solidFill>
+              </a:rPr>
+              <a:t>A text file called </a:t>
+            </a:r>
+            <a:r>
+              <a:rPr lang="en-US" sz="2000" dirty="0">
+                <a:solidFill>
+                  <a:schemeClr val="tx1"/>
+                </a:solidFill>
+                <a:latin typeface="Courier"/>
+                <a:cs typeface="Courier"/>
+              </a:rPr>
+              <a:t>info.txt</a:t>
+            </a:r>
+            <a:r>
+              <a:rPr lang="en-US" sz="2000" dirty="0">
+                <a:solidFill>
+                  <a:schemeClr val="tx1"/>
+                </a:solidFill>
+              </a:rPr>
+              <a:t> which </a:t>
+            </a:r>
+            <a:r>
+              <a:rPr lang="en-US" dirty="0">
+                <a:solidFill>
+                  <a:schemeClr val="tx1"/>
+                </a:solidFill>
+              </a:rPr>
+              <a:t>contains: </a:t>
+            </a:r>
+            <a:br>
+              <a:rPr lang="en-US" dirty="0">
+                <a:solidFill>
+                  <a:schemeClr val="tx1"/>
+                </a:solidFill>
+              </a:rPr>
+            </a:br>
+            <a:br>
+              <a:rPr lang="en-US" dirty="0">
+                <a:solidFill>
+                  <a:schemeClr val="tx1"/>
+                </a:solidFill>
+              </a:rPr>
+            </a:br>
+            <a:r>
+              <a:rPr lang="en-US" dirty="0">
+                <a:solidFill>
+                  <a:schemeClr val="tx1"/>
+                </a:solidFill>
+              </a:rPr>
+              <a:t>“</a:t>
+            </a:r>
+            <a:r>
+              <a:rPr lang="en-US" dirty="0">
+                <a:solidFill>
+                  <a:srgbClr val="00B050"/>
+                </a:solidFill>
+              </a:rPr>
+              <a:t>Audio files can be stored in a variety of formats such as wav, wma, mp3, </a:t>
+            </a:r>
+            <a:r>
+              <a:rPr lang="en-US" dirty="0" err="1">
+                <a:solidFill>
+                  <a:srgbClr val="00B050"/>
+                </a:solidFill>
+              </a:rPr>
+              <a:t>aiff</a:t>
+            </a:r>
+            <a:r>
+              <a:rPr lang="en-US" dirty="0">
+                <a:solidFill>
+                  <a:srgbClr val="00B050"/>
+                </a:solidFill>
+              </a:rPr>
+              <a:t>, au and many others.</a:t>
+            </a:r>
+            <a:r>
+              <a:rPr lang="en-US" dirty="0">
+                <a:solidFill>
+                  <a:schemeClr val="tx1"/>
+                </a:solidFill>
+              </a:rPr>
+              <a:t>” </a:t>
+            </a:r>
+          </a:p>
+          <a:p>
+            <a:endParaRPr lang="en-US" dirty="0">
+              <a:solidFill>
+                <a:schemeClr val="tx1"/>
+              </a:solidFill>
+            </a:endParaRPr>
+          </a:p>
+          <a:p>
+            <a:pPr marL="0" indent="0">
+              <a:buNone/>
+            </a:pPr>
+            <a:r>
+              <a:rPr lang="en-US" b="1" dirty="0">
+                <a:solidFill>
+                  <a:schemeClr val="tx1"/>
+                </a:solidFill>
+              </a:rPr>
+              <a:t>Programs:</a:t>
+            </a:r>
+          </a:p>
+          <a:p>
+            <a:pPr marL="0" indent="0">
+              <a:buNone/>
+            </a:pPr>
+            <a:endParaRPr lang="en-US" dirty="0">
+              <a:solidFill>
+                <a:schemeClr val="tx1"/>
+              </a:solidFill>
+            </a:endParaRPr>
+          </a:p>
+          <a:p>
+            <a:pPr marL="914400" lvl="1" indent="-457200">
+              <a:buFont typeface="+mj-lt"/>
+              <a:buAutoNum type="alphaLcParenR"/>
+            </a:pPr>
+            <a:r>
+              <a:rPr lang="en-US" dirty="0">
+                <a:solidFill>
+                  <a:schemeClr val="tx1"/>
+                </a:solidFill>
+              </a:rPr>
+              <a:t>Print out each character of </a:t>
+            </a:r>
+            <a:r>
+              <a:rPr lang="en-US" sz="1600" dirty="0">
+                <a:solidFill>
+                  <a:schemeClr val="tx1"/>
+                </a:solidFill>
+                <a:latin typeface="Courier"/>
+                <a:cs typeface="Courier"/>
+              </a:rPr>
+              <a:t>info.txt</a:t>
+            </a:r>
+            <a:r>
+              <a:rPr lang="en-US" sz="1600" dirty="0">
+                <a:solidFill>
+                  <a:schemeClr val="tx1"/>
+                </a:solidFill>
+              </a:rPr>
+              <a:t> </a:t>
+            </a:r>
+            <a:r>
+              <a:rPr lang="en-US" dirty="0">
+                <a:solidFill>
+                  <a:schemeClr val="tx1"/>
+                </a:solidFill>
+              </a:rPr>
+              <a:t>on the console.</a:t>
+            </a:r>
+          </a:p>
+          <a:p>
+            <a:pPr marL="914400" lvl="1" indent="-457200">
+              <a:buFont typeface="+mj-lt"/>
+              <a:buAutoNum type="alphaLcParenR"/>
+            </a:pPr>
+            <a:endParaRPr lang="en-US" dirty="0">
+              <a:solidFill>
+                <a:schemeClr val="tx1"/>
+              </a:solidFill>
+            </a:endParaRPr>
+          </a:p>
+          <a:p>
+            <a:pPr marL="914400" lvl="1" indent="-457200">
+              <a:buFont typeface="+mj-lt"/>
+              <a:buAutoNum type="alphaLcParenR"/>
+            </a:pPr>
+            <a:r>
+              <a:rPr lang="en-US" dirty="0">
+                <a:solidFill>
+                  <a:schemeClr val="tx1"/>
+                </a:solidFill>
+              </a:rPr>
+              <a:t>Copy the contents of </a:t>
+            </a:r>
+            <a:r>
+              <a:rPr lang="en-US" sz="1600" dirty="0">
+                <a:solidFill>
+                  <a:schemeClr val="tx1"/>
+                </a:solidFill>
+                <a:latin typeface="Courier"/>
+                <a:cs typeface="Courier"/>
+              </a:rPr>
+              <a:t>info.txt</a:t>
+            </a:r>
+            <a:r>
+              <a:rPr lang="en-US" sz="1600" dirty="0">
+                <a:solidFill>
+                  <a:schemeClr val="tx1"/>
+                </a:solidFill>
+              </a:rPr>
+              <a:t> </a:t>
+            </a:r>
+            <a:r>
+              <a:rPr lang="en-US" dirty="0">
+                <a:solidFill>
+                  <a:schemeClr val="tx1"/>
+                </a:solidFill>
+              </a:rPr>
+              <a:t>to a new file called </a:t>
+            </a:r>
+            <a:r>
+              <a:rPr lang="en-US" sz="1600" dirty="0">
+                <a:solidFill>
+                  <a:schemeClr val="tx1"/>
+                </a:solidFill>
+                <a:latin typeface="Courier"/>
+                <a:cs typeface="Courier"/>
+              </a:rPr>
+              <a:t>copyOfInfo.txt</a:t>
+            </a:r>
+            <a:r>
+              <a:rPr lang="en-US" dirty="0">
+                <a:solidFill>
+                  <a:schemeClr val="tx1"/>
+                </a:solidFill>
+              </a:rPr>
+              <a:t>.</a:t>
+            </a:r>
+          </a:p>
+        </p:txBody>
+      </p:sp>
+      <p:sp>
+        <p:nvSpPr>
+          <p:cNvPr id="4" name="Footer Placeholder 3"/>
+          <p:cNvSpPr>
+            <a:spLocks noGrp="1"/>
+          </p:cNvSpPr>
+          <p:nvPr>
+            <p:ph type="ftr" sz="quarter" idx="11"/>
+          </p:nvPr>
+        </p:nvSpPr>
+        <p:spPr/>
+        <p:txBody>
+          <a:bodyPr/>
+          <a:lstStyle/>
+          <a:p>
+            <a:r>
+              <a:rPr lang="en-US" dirty="0"/>
+              <a:t> </a:t>
+            </a:r>
+          </a:p>
+        </p:txBody>
+      </p:sp>
+      <p:sp>
+        <p:nvSpPr>
+          <p:cNvPr id="5" name="Slide Number Placeholder 4"/>
+          <p:cNvSpPr>
+            <a:spLocks noGrp="1"/>
+          </p:cNvSpPr>
+          <p:nvPr>
+            <p:ph type="sldNum" sz="quarter" idx="12"/>
+          </p:nvPr>
+        </p:nvSpPr>
+        <p:spPr/>
+        <p:txBody>
+          <a:bodyPr/>
+          <a:lstStyle/>
+          <a:p>
+            <a:pPr algn="l"/>
+            <a:r>
+              <a:rPr lang="en-US" dirty="0"/>
+              <a:t> </a:t>
+            </a:r>
+          </a:p>
+        </p:txBody>
+      </p:sp>
+      <p:sp>
+        <p:nvSpPr>
+          <p:cNvPr id="6" name="Content Placeholder 2">
+            <a:extLst>
+              <a:ext uri="{FF2B5EF4-FFF2-40B4-BE49-F238E27FC236}">
+                <a16:creationId xmlns:a16="http://schemas.microsoft.com/office/drawing/2014/main" id="{4CF73B2B-7949-1CDC-F9EB-24B58311D110}"/>
+              </a:ext>
+            </a:extLst>
+          </p:cNvPr>
+          <p:cNvSpPr txBox="1">
+            <a:spLocks/>
+          </p:cNvSpPr>
+          <p:nvPr/>
+        </p:nvSpPr>
+        <p:spPr>
+          <a:xfrm>
+            <a:off x="936516" y="0"/>
+            <a:ext cx="7391328" cy="360606"/>
+          </a:xfrm>
+          <a:prstGeom prst="rect">
+            <a:avLst/>
+          </a:prstGeom>
+          <a:ln w="28575">
+            <a:solidFill>
+              <a:srgbClr val="FF0000"/>
+            </a:solidFill>
+          </a:ln>
+        </p:spPr>
+        <p:txBody>
+          <a:bodyPr vert="horz" lIns="91440" tIns="45720" rIns="91440" bIns="45720" rtlCol="0">
+            <a:normAutofit fontScale="47500" lnSpcReduction="20000"/>
+          </a:bodyPr>
+          <a:lstStyle>
+            <a:lvl1pPr marL="228600" indent="-228600" algn="l" defTabSz="914400" rtl="0" eaLnBrk="1" latinLnBrk="0" hangingPunct="1">
+              <a:lnSpc>
+                <a:spcPct val="90000"/>
+              </a:lnSpc>
+              <a:spcBef>
+                <a:spcPts val="1000"/>
+              </a:spcBef>
+              <a:buClr>
+                <a:srgbClr val="B30738"/>
+              </a:buClr>
+              <a:buFont typeface="Arial" panose="020B0604020202020204" pitchFamily="34" charset="0"/>
+              <a:buChar char="•"/>
+              <a:defRPr sz="2600" b="0" i="0" kern="1200">
+                <a:solidFill>
+                  <a:srgbClr val="002060"/>
+                </a:solidFill>
+                <a:latin typeface="Arial Narrow" panose="020B0604020202020204" pitchFamily="34" charset="0"/>
+                <a:ea typeface="+mn-ea"/>
+                <a:cs typeface="Arial Narrow" panose="020B0604020202020204" pitchFamily="34" charset="0"/>
+              </a:defRPr>
+            </a:lvl1pPr>
+            <a:lvl2pPr marL="685800" indent="-228600" algn="l" defTabSz="914400" rtl="0" eaLnBrk="1" latinLnBrk="0" hangingPunct="1">
+              <a:lnSpc>
+                <a:spcPct val="90000"/>
+              </a:lnSpc>
+              <a:spcBef>
+                <a:spcPts val="500"/>
+              </a:spcBef>
+              <a:buClr>
+                <a:srgbClr val="B30738"/>
+              </a:buClr>
+              <a:buFont typeface="Arial" panose="020B0604020202020204" pitchFamily="34" charset="0"/>
+              <a:buChar char="•"/>
+              <a:defRPr sz="2400" b="0" i="0" kern="1200">
+                <a:solidFill>
+                  <a:schemeClr val="accent2">
+                    <a:lumMod val="75000"/>
+                  </a:schemeClr>
+                </a:solidFill>
+                <a:latin typeface="Arial Narrow" panose="020B0604020202020204" pitchFamily="34" charset="0"/>
+                <a:ea typeface="+mn-ea"/>
+                <a:cs typeface="Arial Narrow" panose="020B0604020202020204" pitchFamily="34" charset="0"/>
+              </a:defRPr>
+            </a:lvl2pPr>
+            <a:lvl3pPr marL="1143000" indent="-228600" algn="l" defTabSz="914400" rtl="0" eaLnBrk="1" latinLnBrk="0" hangingPunct="1">
+              <a:lnSpc>
+                <a:spcPct val="90000"/>
+              </a:lnSpc>
+              <a:spcBef>
+                <a:spcPts val="500"/>
+              </a:spcBef>
+              <a:buClr>
+                <a:srgbClr val="B30738"/>
+              </a:buClr>
+              <a:buFont typeface="Arial" panose="020B0604020202020204" pitchFamily="34" charset="0"/>
+              <a:buChar char="•"/>
+              <a:defRPr sz="2000" b="0" i="0" kern="1200">
+                <a:solidFill>
+                  <a:schemeClr val="tx1">
+                    <a:lumMod val="65000"/>
+                    <a:lumOff val="35000"/>
+                  </a:schemeClr>
+                </a:solidFill>
+                <a:latin typeface="Arial Narrow" panose="020B0604020202020204" pitchFamily="34" charset="0"/>
+                <a:ea typeface="+mn-ea"/>
+                <a:cs typeface="Arial Narrow" panose="020B0604020202020204" pitchFamily="34" charset="0"/>
+              </a:defRPr>
+            </a:lvl3pPr>
+            <a:lvl4pPr marL="1600200" indent="-228600" algn="l" defTabSz="914400" rtl="0" eaLnBrk="1" latinLnBrk="0" hangingPunct="1">
+              <a:lnSpc>
+                <a:spcPct val="90000"/>
+              </a:lnSpc>
+              <a:spcBef>
+                <a:spcPts val="500"/>
+              </a:spcBef>
+              <a:buClr>
+                <a:srgbClr val="B30738"/>
+              </a:buClr>
+              <a:buFont typeface="Arial" panose="020B0604020202020204" pitchFamily="34" charset="0"/>
+              <a:buChar char="•"/>
+              <a:defRPr sz="1800" b="0" i="0" kern="1200">
+                <a:solidFill>
+                  <a:schemeClr val="tx1">
+                    <a:lumMod val="65000"/>
+                    <a:lumOff val="35000"/>
+                  </a:schemeClr>
+                </a:solidFill>
+                <a:latin typeface="Arial Narrow" panose="020B0604020202020204" pitchFamily="34" charset="0"/>
+                <a:ea typeface="+mn-ea"/>
+                <a:cs typeface="Arial Narrow" panose="020B0604020202020204" pitchFamily="34" charset="0"/>
+              </a:defRPr>
+            </a:lvl4pPr>
+            <a:lvl5pPr marL="2057400" indent="-228600" algn="l" defTabSz="914400" rtl="0" eaLnBrk="1" latinLnBrk="0" hangingPunct="1">
+              <a:lnSpc>
+                <a:spcPct val="90000"/>
+              </a:lnSpc>
+              <a:spcBef>
+                <a:spcPts val="500"/>
+              </a:spcBef>
+              <a:buClr>
+                <a:srgbClr val="B30738"/>
+              </a:buClr>
+              <a:buFont typeface="Arial" panose="020B0604020202020204" pitchFamily="34" charset="0"/>
+              <a:buChar char="•"/>
+              <a:defRPr sz="1600" b="0" i="0" kern="1200">
+                <a:solidFill>
+                  <a:schemeClr val="tx1">
+                    <a:lumMod val="65000"/>
+                    <a:lumOff val="35000"/>
+                  </a:schemeClr>
+                </a:solidFill>
+                <a:latin typeface="Arial Narrow" panose="020B0604020202020204" pitchFamily="34" charset="0"/>
+                <a:ea typeface="+mn-ea"/>
+                <a:cs typeface="Arial Narrow" panose="020B0604020202020204" pitchFamily="34" charset="0"/>
+              </a:defRPr>
+            </a:lvl5pPr>
+            <a:lvl6pPr marL="2514600" indent="-228600" algn="l" defTabSz="914400" rtl="0" eaLnBrk="1" latinLnBrk="0" hangingPunct="1">
+              <a:lnSpc>
+                <a:spcPct val="90000"/>
+              </a:lnSpc>
+              <a:spcBef>
+                <a:spcPts val="500"/>
+              </a:spcBef>
+              <a:buFont typeface="Arial" panose="020B0604020202020204" pitchFamily="34" charset="0"/>
+              <a:buChar char="•"/>
+              <a:defRPr sz="1800" kern="1200">
+                <a:solidFill>
+                  <a:schemeClr val="tx1"/>
+                </a:solidFill>
+                <a:latin typeface="+mn-lt"/>
+                <a:ea typeface="+mn-ea"/>
+                <a:cs typeface="+mn-cs"/>
+              </a:defRPr>
+            </a:lvl6pPr>
+            <a:lvl7pPr marL="2971800" indent="-228600" algn="l" defTabSz="914400" rtl="0" eaLnBrk="1" latinLnBrk="0" hangingPunct="1">
+              <a:lnSpc>
+                <a:spcPct val="90000"/>
+              </a:lnSpc>
+              <a:spcBef>
+                <a:spcPts val="500"/>
+              </a:spcBef>
+              <a:buFont typeface="Arial" panose="020B0604020202020204" pitchFamily="34" charset="0"/>
+              <a:buChar char="•"/>
+              <a:defRPr sz="1800" kern="1200">
+                <a:solidFill>
+                  <a:schemeClr val="tx1"/>
+                </a:solidFill>
+                <a:latin typeface="+mn-lt"/>
+                <a:ea typeface="+mn-ea"/>
+                <a:cs typeface="+mn-cs"/>
+              </a:defRPr>
+            </a:lvl7pPr>
+            <a:lvl8pPr marL="3429000" indent="-228600" algn="l" defTabSz="914400" rtl="0" eaLnBrk="1" latinLnBrk="0" hangingPunct="1">
+              <a:lnSpc>
+                <a:spcPct val="90000"/>
+              </a:lnSpc>
+              <a:spcBef>
+                <a:spcPts val="500"/>
+              </a:spcBef>
+              <a:buFont typeface="Arial" panose="020B0604020202020204" pitchFamily="34" charset="0"/>
+              <a:buChar char="•"/>
+              <a:defRPr sz="1800" kern="1200">
+                <a:solidFill>
+                  <a:schemeClr val="tx1"/>
+                </a:solidFill>
+                <a:latin typeface="+mn-lt"/>
+                <a:ea typeface="+mn-ea"/>
+                <a:cs typeface="+mn-cs"/>
+              </a:defRPr>
+            </a:lvl8pPr>
+            <a:lvl9pPr marL="3886200" indent="-228600" algn="l" defTabSz="914400" rtl="0" eaLnBrk="1" latinLnBrk="0" hangingPunct="1">
+              <a:lnSpc>
+                <a:spcPct val="90000"/>
+              </a:lnSpc>
+              <a:spcBef>
+                <a:spcPts val="500"/>
+              </a:spcBef>
+              <a:buFont typeface="Arial" panose="020B0604020202020204" pitchFamily="34" charset="0"/>
+              <a:buChar char="•"/>
+              <a:defRPr sz="1800" kern="1200">
+                <a:solidFill>
+                  <a:schemeClr val="tx1"/>
+                </a:solidFill>
+                <a:latin typeface="+mn-lt"/>
+                <a:ea typeface="+mn-ea"/>
+                <a:cs typeface="+mn-cs"/>
+              </a:defRPr>
+            </a:lvl9pPr>
+          </a:lstStyle>
+          <a:p>
+            <a:pPr marL="0" indent="0" algn="ctr">
+              <a:buNone/>
+              <a:defRPr/>
+            </a:pPr>
+            <a:r>
+              <a:rPr kumimoji="0" lang="en-US" sz="2600" b="0" i="0" u="none" strike="noStrike" kern="1200" cap="none" spc="0" normalizeH="0" baseline="0" noProof="0" dirty="0">
+                <a:ln>
+                  <a:noFill/>
+                </a:ln>
+                <a:solidFill>
+                  <a:srgbClr val="FF0000"/>
+                </a:solidFill>
+                <a:effectLst/>
+                <a:uLnTx/>
+                <a:uFillTx/>
+                <a:latin typeface="+mn-lt"/>
+                <a:ea typeface="+mn-ea"/>
+              </a:rPr>
+              <a:t>CSEN160_06_Lecture_FileIO_AdvancedFileIO_Serialize.scu.csen160.FileIO.</a:t>
+            </a:r>
+            <a:r>
+              <a:rPr lang="en-US" dirty="0" err="1">
+                <a:solidFill>
+                  <a:srgbClr val="FF0000"/>
+                </a:solidFill>
+                <a:latin typeface="+mn-lt"/>
+                <a:cs typeface="Arial" panose="020B0604020202020204" pitchFamily="34" charset="0"/>
+              </a:rPr>
+              <a:t>A_FileReaderExample</a:t>
+            </a:r>
+            <a:endParaRPr kumimoji="0" lang="en-US" sz="2600" b="0" i="0" u="none" strike="noStrike" kern="1200" cap="none" spc="0" normalizeH="0" baseline="0" noProof="0" dirty="0">
+              <a:ln>
+                <a:noFill/>
+              </a:ln>
+              <a:solidFill>
+                <a:srgbClr val="FF0000"/>
+              </a:solidFill>
+              <a:effectLst/>
+              <a:uLnTx/>
+              <a:uFillTx/>
+              <a:latin typeface="+mn-lt"/>
+              <a:ea typeface="+mn-ea"/>
+            </a:endParaRPr>
+          </a:p>
+        </p:txBody>
+      </p:sp>
+    </p:spTree>
+    <p:extLst>
+      <p:ext uri="{BB962C8B-B14F-4D97-AF65-F5344CB8AC3E}">
+        <p14:creationId xmlns:p14="http://schemas.microsoft.com/office/powerpoint/2010/main" val="1688080220"/>
+      </p:ext>
+    </p:extLst>
+  </p:cSld>
+  <p:clrMapOvr>
+    <a:masterClrMapping/>
+  </p:clrMapOvr>
+</p:sld>
+</file>
+
+<file path=ppt/slides/slide80.xml><?xml version="1.0" encoding="utf-8"?>
 <p:sld xmlns:a="http://schemas.openxmlformats.org/drawingml/2006/main" xmlns:r="http://schemas.openxmlformats.org/officeDocument/2006/relationships" xmlns:p="http://schemas.openxmlformats.org/presentationml/2006/main">
   <p:cSld>
     <p:spTree>
@@ -28084,636 +28870,7 @@
 </p:sld>
 </file>
 
-<file path=ppt/slides/slide8.xml><?xml version="1.0" encoding="utf-8"?>
-<p:sld xmlns:a="http://schemas.openxmlformats.org/drawingml/2006/main" xmlns:r="http://schemas.openxmlformats.org/officeDocument/2006/relationships" xmlns:p="http://schemas.openxmlformats.org/presentationml/2006/main">
-  <p:cSld>
-    <p:spTree>
-      <p:nvGrpSpPr>
-        <p:cNvPr id="1" name=""/>
-        <p:cNvGrpSpPr/>
-        <p:nvPr/>
-      </p:nvGrpSpPr>
-      <p:grpSpPr>
-        <a:xfrm>
-          <a:off x="0" y="0"/>
-          <a:ext cx="0" cy="0"/>
-          <a:chOff x="0" y="0"/>
-          <a:chExt cx="0" cy="0"/>
-        </a:xfrm>
-      </p:grpSpPr>
-      <p:sp>
-        <p:nvSpPr>
-          <p:cNvPr id="2" name="Title 1"/>
-          <p:cNvSpPr>
-            <a:spLocks noGrp="1"/>
-          </p:cNvSpPr>
-          <p:nvPr>
-            <p:ph type="title"/>
-          </p:nvPr>
-        </p:nvSpPr>
-        <p:spPr>
-          <a:xfrm>
-            <a:off x="936516" y="749511"/>
-            <a:ext cx="3987488" cy="662549"/>
-          </a:xfrm>
-        </p:spPr>
-        <p:txBody>
-          <a:bodyPr>
-            <a:normAutofit/>
-          </a:bodyPr>
-          <a:lstStyle/>
-          <a:p>
-            <a:r>
-              <a:rPr lang="en-US" dirty="0"/>
-              <a:t>IntelliJ example</a:t>
-            </a:r>
-          </a:p>
-        </p:txBody>
-      </p:sp>
-      <p:sp>
-        <p:nvSpPr>
-          <p:cNvPr id="3" name="Content Placeholder 2"/>
-          <p:cNvSpPr>
-            <a:spLocks noGrp="1"/>
-          </p:cNvSpPr>
-          <p:nvPr>
-            <p:ph idx="1"/>
-          </p:nvPr>
-        </p:nvSpPr>
-        <p:spPr>
-          <a:xfrm>
-            <a:off x="936516" y="1822253"/>
-            <a:ext cx="10388288" cy="4809170"/>
-          </a:xfrm>
-        </p:spPr>
-        <p:txBody>
-          <a:bodyPr/>
-          <a:lstStyle/>
-          <a:p>
-            <a:pPr marL="0" indent="0">
-              <a:buNone/>
-            </a:pPr>
-            <a:r>
-              <a:rPr lang="en-US" dirty="0">
-                <a:solidFill>
-                  <a:schemeClr val="tx1"/>
-                </a:solidFill>
-              </a:rPr>
-              <a:t>A text file called </a:t>
-            </a:r>
-            <a:r>
-              <a:rPr lang="en-US" sz="2000" dirty="0">
-                <a:solidFill>
-                  <a:schemeClr val="tx1"/>
-                </a:solidFill>
-                <a:latin typeface="Courier"/>
-                <a:cs typeface="Courier"/>
-              </a:rPr>
-              <a:t>info.txt</a:t>
-            </a:r>
-            <a:r>
-              <a:rPr lang="en-US" sz="2000" dirty="0">
-                <a:solidFill>
-                  <a:schemeClr val="tx1"/>
-                </a:solidFill>
-              </a:rPr>
-              <a:t> which </a:t>
-            </a:r>
-            <a:r>
-              <a:rPr lang="en-US" dirty="0">
-                <a:solidFill>
-                  <a:schemeClr val="tx1"/>
-                </a:solidFill>
-              </a:rPr>
-              <a:t>contains: </a:t>
-            </a:r>
-            <a:br>
-              <a:rPr lang="en-US" dirty="0">
-                <a:solidFill>
-                  <a:schemeClr val="tx1"/>
-                </a:solidFill>
-              </a:rPr>
-            </a:br>
-            <a:br>
-              <a:rPr lang="en-US" dirty="0">
-                <a:solidFill>
-                  <a:schemeClr val="tx1"/>
-                </a:solidFill>
-              </a:rPr>
-            </a:br>
-            <a:r>
-              <a:rPr lang="en-US" dirty="0">
-                <a:solidFill>
-                  <a:schemeClr val="tx1"/>
-                </a:solidFill>
-              </a:rPr>
-              <a:t>“</a:t>
-            </a:r>
-            <a:r>
-              <a:rPr lang="en-US" dirty="0">
-                <a:solidFill>
-                  <a:srgbClr val="00B050"/>
-                </a:solidFill>
-              </a:rPr>
-              <a:t>Audio files can be stored in a variety of formats such as wav, wma, mp3, </a:t>
-            </a:r>
-            <a:r>
-              <a:rPr lang="en-US" dirty="0" err="1">
-                <a:solidFill>
-                  <a:srgbClr val="00B050"/>
-                </a:solidFill>
-              </a:rPr>
-              <a:t>aiff</a:t>
-            </a:r>
-            <a:r>
-              <a:rPr lang="en-US" dirty="0">
-                <a:solidFill>
-                  <a:srgbClr val="00B050"/>
-                </a:solidFill>
-              </a:rPr>
-              <a:t>, au and many others.</a:t>
-            </a:r>
-            <a:r>
-              <a:rPr lang="en-US" dirty="0">
-                <a:solidFill>
-                  <a:schemeClr val="tx1"/>
-                </a:solidFill>
-              </a:rPr>
-              <a:t>” </a:t>
-            </a:r>
-          </a:p>
-          <a:p>
-            <a:endParaRPr lang="en-US" dirty="0">
-              <a:solidFill>
-                <a:schemeClr val="tx1"/>
-              </a:solidFill>
-            </a:endParaRPr>
-          </a:p>
-          <a:p>
-            <a:pPr marL="0" indent="0">
-              <a:buNone/>
-            </a:pPr>
-            <a:r>
-              <a:rPr lang="en-US" b="1" dirty="0">
-                <a:solidFill>
-                  <a:schemeClr val="tx1"/>
-                </a:solidFill>
-              </a:rPr>
-              <a:t>Programs:</a:t>
-            </a:r>
-          </a:p>
-          <a:p>
-            <a:pPr marL="0" indent="0">
-              <a:buNone/>
-            </a:pPr>
-            <a:endParaRPr lang="en-US" dirty="0">
-              <a:solidFill>
-                <a:schemeClr val="tx1"/>
-              </a:solidFill>
-            </a:endParaRPr>
-          </a:p>
-          <a:p>
-            <a:pPr marL="914400" lvl="1" indent="-457200">
-              <a:buFont typeface="+mj-lt"/>
-              <a:buAutoNum type="alphaLcParenR"/>
-            </a:pPr>
-            <a:r>
-              <a:rPr lang="en-US" dirty="0">
-                <a:solidFill>
-                  <a:schemeClr val="tx1"/>
-                </a:solidFill>
-              </a:rPr>
-              <a:t>Print out each character of </a:t>
-            </a:r>
-            <a:r>
-              <a:rPr lang="en-US" sz="1600" dirty="0">
-                <a:solidFill>
-                  <a:schemeClr val="tx1"/>
-                </a:solidFill>
-                <a:latin typeface="Courier"/>
-                <a:cs typeface="Courier"/>
-              </a:rPr>
-              <a:t>info.txt</a:t>
-            </a:r>
-            <a:r>
-              <a:rPr lang="en-US" sz="1600" dirty="0">
-                <a:solidFill>
-                  <a:schemeClr val="tx1"/>
-                </a:solidFill>
-              </a:rPr>
-              <a:t> </a:t>
-            </a:r>
-            <a:r>
-              <a:rPr lang="en-US" dirty="0">
-                <a:solidFill>
-                  <a:schemeClr val="tx1"/>
-                </a:solidFill>
-              </a:rPr>
-              <a:t>on the console.</a:t>
-            </a:r>
-          </a:p>
-          <a:p>
-            <a:pPr marL="914400" lvl="1" indent="-457200">
-              <a:buFont typeface="+mj-lt"/>
-              <a:buAutoNum type="alphaLcParenR"/>
-            </a:pPr>
-            <a:endParaRPr lang="en-US" dirty="0">
-              <a:solidFill>
-                <a:schemeClr val="tx1"/>
-              </a:solidFill>
-            </a:endParaRPr>
-          </a:p>
-          <a:p>
-            <a:pPr marL="914400" lvl="1" indent="-457200">
-              <a:buFont typeface="+mj-lt"/>
-              <a:buAutoNum type="alphaLcParenR"/>
-            </a:pPr>
-            <a:r>
-              <a:rPr lang="en-US" dirty="0">
-                <a:solidFill>
-                  <a:schemeClr val="tx1"/>
-                </a:solidFill>
-              </a:rPr>
-              <a:t>Copy the contents of </a:t>
-            </a:r>
-            <a:r>
-              <a:rPr lang="en-US" sz="1600" dirty="0">
-                <a:solidFill>
-                  <a:schemeClr val="tx1"/>
-                </a:solidFill>
-                <a:latin typeface="Courier"/>
-                <a:cs typeface="Courier"/>
-              </a:rPr>
-              <a:t>info.txt</a:t>
-            </a:r>
-            <a:r>
-              <a:rPr lang="en-US" sz="1600" dirty="0">
-                <a:solidFill>
-                  <a:schemeClr val="tx1"/>
-                </a:solidFill>
-              </a:rPr>
-              <a:t> </a:t>
-            </a:r>
-            <a:r>
-              <a:rPr lang="en-US" dirty="0">
-                <a:solidFill>
-                  <a:schemeClr val="tx1"/>
-                </a:solidFill>
-              </a:rPr>
-              <a:t>to a new file called </a:t>
-            </a:r>
-            <a:r>
-              <a:rPr lang="en-US" sz="1600" dirty="0">
-                <a:solidFill>
-                  <a:schemeClr val="tx1"/>
-                </a:solidFill>
-                <a:latin typeface="Courier"/>
-                <a:cs typeface="Courier"/>
-              </a:rPr>
-              <a:t>copyOfInfo.txt</a:t>
-            </a:r>
-            <a:r>
-              <a:rPr lang="en-US" dirty="0">
-                <a:solidFill>
-                  <a:schemeClr val="tx1"/>
-                </a:solidFill>
-              </a:rPr>
-              <a:t>.</a:t>
-            </a:r>
-          </a:p>
-        </p:txBody>
-      </p:sp>
-      <p:sp>
-        <p:nvSpPr>
-          <p:cNvPr id="4" name="Footer Placeholder 3"/>
-          <p:cNvSpPr>
-            <a:spLocks noGrp="1"/>
-          </p:cNvSpPr>
-          <p:nvPr>
-            <p:ph type="ftr" sz="quarter" idx="11"/>
-          </p:nvPr>
-        </p:nvSpPr>
-        <p:spPr/>
-        <p:txBody>
-          <a:bodyPr/>
-          <a:lstStyle/>
-          <a:p>
-            <a:r>
-              <a:rPr lang="en-US" dirty="0"/>
-              <a:t> </a:t>
-            </a:r>
-          </a:p>
-        </p:txBody>
-      </p:sp>
-      <p:sp>
-        <p:nvSpPr>
-          <p:cNvPr id="5" name="Slide Number Placeholder 4"/>
-          <p:cNvSpPr>
-            <a:spLocks noGrp="1"/>
-          </p:cNvSpPr>
-          <p:nvPr>
-            <p:ph type="sldNum" sz="quarter" idx="12"/>
-          </p:nvPr>
-        </p:nvSpPr>
-        <p:spPr/>
-        <p:txBody>
-          <a:bodyPr/>
-          <a:lstStyle/>
-          <a:p>
-            <a:pPr algn="l"/>
-            <a:r>
-              <a:rPr lang="en-US" dirty="0"/>
-              <a:t> </a:t>
-            </a:r>
-          </a:p>
-        </p:txBody>
-      </p:sp>
-      <p:sp>
-        <p:nvSpPr>
-          <p:cNvPr id="6" name="Content Placeholder 2">
-            <a:extLst>
-              <a:ext uri="{FF2B5EF4-FFF2-40B4-BE49-F238E27FC236}">
-                <a16:creationId xmlns:a16="http://schemas.microsoft.com/office/drawing/2014/main" id="{4CF73B2B-7949-1CDC-F9EB-24B58311D110}"/>
-              </a:ext>
-            </a:extLst>
-          </p:cNvPr>
-          <p:cNvSpPr txBox="1">
-            <a:spLocks/>
-          </p:cNvSpPr>
-          <p:nvPr/>
-        </p:nvSpPr>
-        <p:spPr>
-          <a:xfrm>
-            <a:off x="936516" y="0"/>
-            <a:ext cx="7391328" cy="360606"/>
-          </a:xfrm>
-          <a:prstGeom prst="rect">
-            <a:avLst/>
-          </a:prstGeom>
-          <a:ln w="28575">
-            <a:solidFill>
-              <a:srgbClr val="FF0000"/>
-            </a:solidFill>
-          </a:ln>
-        </p:spPr>
-        <p:txBody>
-          <a:bodyPr vert="horz" lIns="91440" tIns="45720" rIns="91440" bIns="45720" rtlCol="0">
-            <a:normAutofit fontScale="47500" lnSpcReduction="20000"/>
-          </a:bodyPr>
-          <a:lstStyle>
-            <a:lvl1pPr marL="228600" indent="-228600" algn="l" defTabSz="914400" rtl="0" eaLnBrk="1" latinLnBrk="0" hangingPunct="1">
-              <a:lnSpc>
-                <a:spcPct val="90000"/>
-              </a:lnSpc>
-              <a:spcBef>
-                <a:spcPts val="1000"/>
-              </a:spcBef>
-              <a:buClr>
-                <a:srgbClr val="B30738"/>
-              </a:buClr>
-              <a:buFont typeface="Arial" panose="020B0604020202020204" pitchFamily="34" charset="0"/>
-              <a:buChar char="•"/>
-              <a:defRPr sz="2600" b="0" i="0" kern="1200">
-                <a:solidFill>
-                  <a:srgbClr val="002060"/>
-                </a:solidFill>
-                <a:latin typeface="Arial Narrow" panose="020B0604020202020204" pitchFamily="34" charset="0"/>
-                <a:ea typeface="+mn-ea"/>
-                <a:cs typeface="Arial Narrow" panose="020B0604020202020204" pitchFamily="34" charset="0"/>
-              </a:defRPr>
-            </a:lvl1pPr>
-            <a:lvl2pPr marL="685800" indent="-228600" algn="l" defTabSz="914400" rtl="0" eaLnBrk="1" latinLnBrk="0" hangingPunct="1">
-              <a:lnSpc>
-                <a:spcPct val="90000"/>
-              </a:lnSpc>
-              <a:spcBef>
-                <a:spcPts val="500"/>
-              </a:spcBef>
-              <a:buClr>
-                <a:srgbClr val="B30738"/>
-              </a:buClr>
-              <a:buFont typeface="Arial" panose="020B0604020202020204" pitchFamily="34" charset="0"/>
-              <a:buChar char="•"/>
-              <a:defRPr sz="2400" b="0" i="0" kern="1200">
-                <a:solidFill>
-                  <a:schemeClr val="accent2">
-                    <a:lumMod val="75000"/>
-                  </a:schemeClr>
-                </a:solidFill>
-                <a:latin typeface="Arial Narrow" panose="020B0604020202020204" pitchFamily="34" charset="0"/>
-                <a:ea typeface="+mn-ea"/>
-                <a:cs typeface="Arial Narrow" panose="020B0604020202020204" pitchFamily="34" charset="0"/>
-              </a:defRPr>
-            </a:lvl2pPr>
-            <a:lvl3pPr marL="1143000" indent="-228600" algn="l" defTabSz="914400" rtl="0" eaLnBrk="1" latinLnBrk="0" hangingPunct="1">
-              <a:lnSpc>
-                <a:spcPct val="90000"/>
-              </a:lnSpc>
-              <a:spcBef>
-                <a:spcPts val="500"/>
-              </a:spcBef>
-              <a:buClr>
-                <a:srgbClr val="B30738"/>
-              </a:buClr>
-              <a:buFont typeface="Arial" panose="020B0604020202020204" pitchFamily="34" charset="0"/>
-              <a:buChar char="•"/>
-              <a:defRPr sz="2000" b="0" i="0" kern="1200">
-                <a:solidFill>
-                  <a:schemeClr val="tx1">
-                    <a:lumMod val="65000"/>
-                    <a:lumOff val="35000"/>
-                  </a:schemeClr>
-                </a:solidFill>
-                <a:latin typeface="Arial Narrow" panose="020B0604020202020204" pitchFamily="34" charset="0"/>
-                <a:ea typeface="+mn-ea"/>
-                <a:cs typeface="Arial Narrow" panose="020B0604020202020204" pitchFamily="34" charset="0"/>
-              </a:defRPr>
-            </a:lvl3pPr>
-            <a:lvl4pPr marL="1600200" indent="-228600" algn="l" defTabSz="914400" rtl="0" eaLnBrk="1" latinLnBrk="0" hangingPunct="1">
-              <a:lnSpc>
-                <a:spcPct val="90000"/>
-              </a:lnSpc>
-              <a:spcBef>
-                <a:spcPts val="500"/>
-              </a:spcBef>
-              <a:buClr>
-                <a:srgbClr val="B30738"/>
-              </a:buClr>
-              <a:buFont typeface="Arial" panose="020B0604020202020204" pitchFamily="34" charset="0"/>
-              <a:buChar char="•"/>
-              <a:defRPr sz="1800" b="0" i="0" kern="1200">
-                <a:solidFill>
-                  <a:schemeClr val="tx1">
-                    <a:lumMod val="65000"/>
-                    <a:lumOff val="35000"/>
-                  </a:schemeClr>
-                </a:solidFill>
-                <a:latin typeface="Arial Narrow" panose="020B0604020202020204" pitchFamily="34" charset="0"/>
-                <a:ea typeface="+mn-ea"/>
-                <a:cs typeface="Arial Narrow" panose="020B0604020202020204" pitchFamily="34" charset="0"/>
-              </a:defRPr>
-            </a:lvl4pPr>
-            <a:lvl5pPr marL="2057400" indent="-228600" algn="l" defTabSz="914400" rtl="0" eaLnBrk="1" latinLnBrk="0" hangingPunct="1">
-              <a:lnSpc>
-                <a:spcPct val="90000"/>
-              </a:lnSpc>
-              <a:spcBef>
-                <a:spcPts val="500"/>
-              </a:spcBef>
-              <a:buClr>
-                <a:srgbClr val="B30738"/>
-              </a:buClr>
-              <a:buFont typeface="Arial" panose="020B0604020202020204" pitchFamily="34" charset="0"/>
-              <a:buChar char="•"/>
-              <a:defRPr sz="1600" b="0" i="0" kern="1200">
-                <a:solidFill>
-                  <a:schemeClr val="tx1">
-                    <a:lumMod val="65000"/>
-                    <a:lumOff val="35000"/>
-                  </a:schemeClr>
-                </a:solidFill>
-                <a:latin typeface="Arial Narrow" panose="020B0604020202020204" pitchFamily="34" charset="0"/>
-                <a:ea typeface="+mn-ea"/>
-                <a:cs typeface="Arial Narrow" panose="020B0604020202020204" pitchFamily="34" charset="0"/>
-              </a:defRPr>
-            </a:lvl5pPr>
-            <a:lvl6pPr marL="2514600" indent="-228600" algn="l" defTabSz="914400" rtl="0" eaLnBrk="1" latinLnBrk="0" hangingPunct="1">
-              <a:lnSpc>
-                <a:spcPct val="90000"/>
-              </a:lnSpc>
-              <a:spcBef>
-                <a:spcPts val="500"/>
-              </a:spcBef>
-              <a:buFont typeface="Arial" panose="020B0604020202020204" pitchFamily="34" charset="0"/>
-              <a:buChar char="•"/>
-              <a:defRPr sz="1800" kern="1200">
-                <a:solidFill>
-                  <a:schemeClr val="tx1"/>
-                </a:solidFill>
-                <a:latin typeface="+mn-lt"/>
-                <a:ea typeface="+mn-ea"/>
-                <a:cs typeface="+mn-cs"/>
-              </a:defRPr>
-            </a:lvl6pPr>
-            <a:lvl7pPr marL="2971800" indent="-228600" algn="l" defTabSz="914400" rtl="0" eaLnBrk="1" latinLnBrk="0" hangingPunct="1">
-              <a:lnSpc>
-                <a:spcPct val="90000"/>
-              </a:lnSpc>
-              <a:spcBef>
-                <a:spcPts val="500"/>
-              </a:spcBef>
-              <a:buFont typeface="Arial" panose="020B0604020202020204" pitchFamily="34" charset="0"/>
-              <a:buChar char="•"/>
-              <a:defRPr sz="1800" kern="1200">
-                <a:solidFill>
-                  <a:schemeClr val="tx1"/>
-                </a:solidFill>
-                <a:latin typeface="+mn-lt"/>
-                <a:ea typeface="+mn-ea"/>
-                <a:cs typeface="+mn-cs"/>
-              </a:defRPr>
-            </a:lvl7pPr>
-            <a:lvl8pPr marL="3429000" indent="-228600" algn="l" defTabSz="914400" rtl="0" eaLnBrk="1" latinLnBrk="0" hangingPunct="1">
-              <a:lnSpc>
-                <a:spcPct val="90000"/>
-              </a:lnSpc>
-              <a:spcBef>
-                <a:spcPts val="500"/>
-              </a:spcBef>
-              <a:buFont typeface="Arial" panose="020B0604020202020204" pitchFamily="34" charset="0"/>
-              <a:buChar char="•"/>
-              <a:defRPr sz="1800" kern="1200">
-                <a:solidFill>
-                  <a:schemeClr val="tx1"/>
-                </a:solidFill>
-                <a:latin typeface="+mn-lt"/>
-                <a:ea typeface="+mn-ea"/>
-                <a:cs typeface="+mn-cs"/>
-              </a:defRPr>
-            </a:lvl8pPr>
-            <a:lvl9pPr marL="3886200" indent="-228600" algn="l" defTabSz="914400" rtl="0" eaLnBrk="1" latinLnBrk="0" hangingPunct="1">
-              <a:lnSpc>
-                <a:spcPct val="90000"/>
-              </a:lnSpc>
-              <a:spcBef>
-                <a:spcPts val="500"/>
-              </a:spcBef>
-              <a:buFont typeface="Arial" panose="020B0604020202020204" pitchFamily="34" charset="0"/>
-              <a:buChar char="•"/>
-              <a:defRPr sz="1800" kern="1200">
-                <a:solidFill>
-                  <a:schemeClr val="tx1"/>
-                </a:solidFill>
-                <a:latin typeface="+mn-lt"/>
-                <a:ea typeface="+mn-ea"/>
-                <a:cs typeface="+mn-cs"/>
-              </a:defRPr>
-            </a:lvl9pPr>
-          </a:lstStyle>
-          <a:p>
-            <a:pPr marL="0" indent="0" algn="ctr">
-              <a:buNone/>
-              <a:defRPr/>
-            </a:pPr>
-            <a:r>
-              <a:rPr kumimoji="0" lang="en-US" sz="2600" b="0" i="0" u="none" strike="noStrike" kern="1200" cap="none" spc="0" normalizeH="0" baseline="0" noProof="0" dirty="0">
-                <a:ln>
-                  <a:noFill/>
-                </a:ln>
-                <a:solidFill>
-                  <a:srgbClr val="FF0000"/>
-                </a:solidFill>
-                <a:effectLst/>
-                <a:uLnTx/>
-                <a:uFillTx/>
-                <a:latin typeface="+mn-lt"/>
-                <a:ea typeface="+mn-ea"/>
-              </a:rPr>
-              <a:t>“CSEN160_06_Lecture_FileIO_AdvancedFileIO_Serialize.scu.csen160.</a:t>
-            </a:r>
-            <a:r>
-              <a:rPr lang="en-US" dirty="0" err="1">
-                <a:solidFill>
-                  <a:srgbClr val="FF0000"/>
-                </a:solidFill>
-                <a:latin typeface="+mn-lt"/>
-                <a:cs typeface="Arial" panose="020B0604020202020204" pitchFamily="34" charset="0"/>
-              </a:rPr>
-              <a:t>A_FileReaderExample</a:t>
-            </a:r>
-            <a:r>
-              <a:rPr kumimoji="0" lang="en-US" sz="2600" b="0" i="0" u="none" strike="noStrike" kern="1200" cap="none" spc="0" normalizeH="0" baseline="0" noProof="0" dirty="0">
-                <a:ln>
-                  <a:noFill/>
-                </a:ln>
-                <a:solidFill>
-                  <a:srgbClr val="FF0000"/>
-                </a:solidFill>
-                <a:effectLst/>
-                <a:uLnTx/>
-                <a:uFillTx/>
-                <a:latin typeface="+mn-lt"/>
-                <a:ea typeface="+mn-ea"/>
-              </a:rPr>
-              <a:t>”</a:t>
-            </a:r>
-          </a:p>
-        </p:txBody>
-      </p:sp>
-    </p:spTree>
-    <p:extLst>
-      <p:ext uri="{BB962C8B-B14F-4D97-AF65-F5344CB8AC3E}">
-        <p14:creationId xmlns:p14="http://schemas.microsoft.com/office/powerpoint/2010/main" val="1688080220"/>
-      </p:ext>
-    </p:extLst>
-  </p:cSld>
-  <p:clrMapOvr>
-    <a:masterClrMapping/>
-  </p:clrMapOvr>
-</p:sld>
-</file>
-
-<file path=ppt/slides/slide80.xml><?xml version="1.0" encoding="utf-8"?>
+<file path=ppt/slides/slide81.xml><?xml version="1.0" encoding="utf-8"?>
 <p:sld xmlns:a="http://schemas.openxmlformats.org/drawingml/2006/main" xmlns:r="http://schemas.openxmlformats.org/officeDocument/2006/relationships" xmlns:p="http://schemas.openxmlformats.org/presentationml/2006/main">
   <p:cSld>
     <p:spTree>
@@ -28943,264 +29100,6 @@
     <p:extLst>
       <p:ext uri="{BB962C8B-B14F-4D97-AF65-F5344CB8AC3E}">
         <p14:creationId xmlns:p14="http://schemas.microsoft.com/office/powerpoint/2010/main" val="3501028715"/>
-      </p:ext>
-    </p:extLst>
-  </p:cSld>
-  <p:clrMapOvr>
-    <a:masterClrMapping/>
-  </p:clrMapOvr>
-</p:sld>
-</file>
-
-<file path=ppt/slides/slide81.xml><?xml version="1.0" encoding="utf-8"?>
-<p:sld xmlns:a="http://schemas.openxmlformats.org/drawingml/2006/main" xmlns:r="http://schemas.openxmlformats.org/officeDocument/2006/relationships" xmlns:p="http://schemas.openxmlformats.org/presentationml/2006/main">
-  <p:cSld>
-    <p:spTree>
-      <p:nvGrpSpPr>
-        <p:cNvPr id="1" name=""/>
-        <p:cNvGrpSpPr/>
-        <p:nvPr/>
-      </p:nvGrpSpPr>
-      <p:grpSpPr>
-        <a:xfrm>
-          <a:off x="0" y="0"/>
-          <a:ext cx="0" cy="0"/>
-          <a:chOff x="0" y="0"/>
-          <a:chExt cx="0" cy="0"/>
-        </a:xfrm>
-      </p:grpSpPr>
-      <p:sp>
-        <p:nvSpPr>
-          <p:cNvPr id="2" name="Title 1"/>
-          <p:cNvSpPr>
-            <a:spLocks noGrp="1"/>
-          </p:cNvSpPr>
-          <p:nvPr>
-            <p:ph type="title"/>
-          </p:nvPr>
-        </p:nvSpPr>
-        <p:spPr>
-          <a:xfrm>
-            <a:off x="936516" y="761650"/>
-            <a:ext cx="5067774" cy="771792"/>
-          </a:xfrm>
-        </p:spPr>
-        <p:txBody>
-          <a:bodyPr/>
-          <a:lstStyle/>
-          <a:p>
-            <a:r>
-              <a:rPr lang="en-US" dirty="0"/>
-              <a:t>Object </a:t>
-            </a:r>
-            <a:r>
-              <a:rPr lang="en-US" dirty="0" err="1"/>
-              <a:t>Deserialization</a:t>
-            </a:r>
-            <a:endParaRPr lang="en-US" dirty="0"/>
-          </a:p>
-        </p:txBody>
-      </p:sp>
-      <p:sp>
-        <p:nvSpPr>
-          <p:cNvPr id="3" name="Content Placeholder 2"/>
-          <p:cNvSpPr>
-            <a:spLocks noGrp="1"/>
-          </p:cNvSpPr>
-          <p:nvPr>
-            <p:ph idx="1"/>
-          </p:nvPr>
-        </p:nvSpPr>
-        <p:spPr>
-          <a:xfrm>
-            <a:off x="936516" y="1846529"/>
-            <a:ext cx="10400426" cy="4788940"/>
-          </a:xfrm>
-        </p:spPr>
-        <p:txBody>
-          <a:bodyPr/>
-          <a:lstStyle/>
-          <a:p>
-            <a:pPr>
-              <a:buNone/>
-            </a:pPr>
-            <a:r>
-              <a:rPr lang="en-US" b="1" dirty="0">
-                <a:solidFill>
-                  <a:schemeClr val="tx1"/>
-                </a:solidFill>
-              </a:rPr>
-              <a:t>Object is </a:t>
-            </a:r>
-            <a:r>
-              <a:rPr lang="en-US" b="1" dirty="0" err="1">
-                <a:solidFill>
-                  <a:schemeClr val="tx1"/>
-                </a:solidFill>
-              </a:rPr>
-              <a:t>deserialized</a:t>
-            </a:r>
-            <a:r>
-              <a:rPr lang="en-US" b="1" dirty="0">
-                <a:solidFill>
-                  <a:schemeClr val="tx1"/>
-                </a:solidFill>
-              </a:rPr>
-              <a:t> using the following steps:</a:t>
-            </a:r>
-          </a:p>
-          <a:p>
-            <a:pPr>
-              <a:buNone/>
-            </a:pPr>
-            <a:endParaRPr lang="en-US" dirty="0">
-              <a:solidFill>
-                <a:schemeClr val="tx1"/>
-              </a:solidFill>
-            </a:endParaRPr>
-          </a:p>
-          <a:p>
-            <a:pPr>
-              <a:buNone/>
-            </a:pPr>
-            <a:r>
-              <a:rPr lang="en-US" dirty="0">
-                <a:solidFill>
-                  <a:schemeClr val="tx1"/>
-                </a:solidFill>
-              </a:rPr>
-              <a:t>1. Create a </a:t>
-            </a:r>
-            <a:r>
-              <a:rPr lang="en-US" sz="2000" dirty="0" err="1">
-                <a:solidFill>
-                  <a:schemeClr val="tx1"/>
-                </a:solidFill>
-                <a:latin typeface="Courier"/>
-                <a:cs typeface="Courier"/>
-              </a:rPr>
-              <a:t>FileInputStream</a:t>
-            </a:r>
-            <a:r>
-              <a:rPr lang="en-US" sz="2000" dirty="0">
-                <a:solidFill>
-                  <a:schemeClr val="tx1"/>
-                </a:solidFill>
-              </a:rPr>
-              <a:t> </a:t>
-            </a:r>
-            <a:r>
-              <a:rPr lang="en-US" dirty="0">
-                <a:solidFill>
-                  <a:schemeClr val="tx1"/>
-                </a:solidFill>
-              </a:rPr>
-              <a:t>to read from a file, </a:t>
-            </a:r>
-            <a:br>
-              <a:rPr lang="en-US" dirty="0">
-                <a:solidFill>
-                  <a:schemeClr val="tx1"/>
-                </a:solidFill>
-              </a:rPr>
-            </a:br>
-            <a:r>
-              <a:rPr lang="en-US" dirty="0">
-                <a:solidFill>
-                  <a:schemeClr val="tx1"/>
-                </a:solidFill>
-              </a:rPr>
-              <a:t>wrap it inside an </a:t>
-            </a:r>
-            <a:r>
-              <a:rPr lang="en-US" sz="2000" dirty="0" err="1">
-                <a:solidFill>
-                  <a:schemeClr val="tx1"/>
-                </a:solidFill>
-                <a:latin typeface="Courier"/>
-                <a:cs typeface="Courier"/>
-              </a:rPr>
-              <a:t>ObjectInputStream</a:t>
-            </a:r>
-            <a:r>
-              <a:rPr lang="en-US" dirty="0">
-                <a:solidFill>
-                  <a:schemeClr val="tx1"/>
-                </a:solidFill>
-              </a:rPr>
-              <a:t>.</a:t>
-            </a:r>
-          </a:p>
-          <a:p>
-            <a:pPr>
-              <a:buNone/>
-            </a:pPr>
-            <a:endParaRPr lang="en-US" dirty="0">
-              <a:solidFill>
-                <a:schemeClr val="tx1"/>
-              </a:solidFill>
-            </a:endParaRPr>
-          </a:p>
-          <a:p>
-            <a:pPr>
-              <a:buNone/>
-            </a:pPr>
-            <a:r>
-              <a:rPr lang="en-US" dirty="0">
-                <a:solidFill>
-                  <a:schemeClr val="tx1"/>
-                </a:solidFill>
-              </a:rPr>
-              <a:t>2. Invoke the object stream’s </a:t>
-            </a:r>
-            <a:r>
-              <a:rPr lang="en-US" sz="2000" dirty="0" err="1">
-                <a:solidFill>
-                  <a:schemeClr val="tx1"/>
-                </a:solidFill>
-                <a:latin typeface="Courier"/>
-                <a:cs typeface="Courier"/>
-              </a:rPr>
-              <a:t>readObject</a:t>
-            </a:r>
-            <a:r>
-              <a:rPr lang="en-US" sz="2000" dirty="0">
-                <a:solidFill>
-                  <a:schemeClr val="tx1"/>
-                </a:solidFill>
-              </a:rPr>
-              <a:t> </a:t>
-            </a:r>
-            <a:r>
-              <a:rPr lang="en-US" dirty="0">
-                <a:solidFill>
-                  <a:schemeClr val="tx1"/>
-                </a:solidFill>
-              </a:rPr>
-              <a:t>method, </a:t>
-            </a:r>
-            <a:br>
-              <a:rPr lang="en-US" dirty="0">
-                <a:solidFill>
-                  <a:schemeClr val="tx1"/>
-                </a:solidFill>
-              </a:rPr>
-            </a:br>
-            <a:r>
-              <a:rPr lang="en-US" dirty="0">
-                <a:solidFill>
-                  <a:schemeClr val="tx1"/>
-                </a:solidFill>
-              </a:rPr>
-              <a:t>to restore the object’s state.</a:t>
-            </a:r>
-          </a:p>
-        </p:txBody>
-      </p:sp>
-    </p:spTree>
-    <p:extLst>
-      <p:ext uri="{BB962C8B-B14F-4D97-AF65-F5344CB8AC3E}">
-        <p14:creationId xmlns:p14="http://schemas.microsoft.com/office/powerpoint/2010/main" val="1199201847"/>
       </p:ext>
     </p:extLst>
   </p:cSld>
@@ -29239,6 +29138,264 @@
         </p:nvSpPr>
         <p:spPr>
           <a:xfrm>
+            <a:off x="936516" y="761650"/>
+            <a:ext cx="5067774" cy="771792"/>
+          </a:xfrm>
+        </p:spPr>
+        <p:txBody>
+          <a:bodyPr/>
+          <a:lstStyle/>
+          <a:p>
+            <a:r>
+              <a:rPr lang="en-US" dirty="0"/>
+              <a:t>Object </a:t>
+            </a:r>
+            <a:r>
+              <a:rPr lang="en-US" dirty="0" err="1"/>
+              <a:t>Deserialization</a:t>
+            </a:r>
+            <a:endParaRPr lang="en-US" dirty="0"/>
+          </a:p>
+        </p:txBody>
+      </p:sp>
+      <p:sp>
+        <p:nvSpPr>
+          <p:cNvPr id="3" name="Content Placeholder 2"/>
+          <p:cNvSpPr>
+            <a:spLocks noGrp="1"/>
+          </p:cNvSpPr>
+          <p:nvPr>
+            <p:ph idx="1"/>
+          </p:nvPr>
+        </p:nvSpPr>
+        <p:spPr>
+          <a:xfrm>
+            <a:off x="936516" y="1846529"/>
+            <a:ext cx="10400426" cy="4788940"/>
+          </a:xfrm>
+        </p:spPr>
+        <p:txBody>
+          <a:bodyPr/>
+          <a:lstStyle/>
+          <a:p>
+            <a:pPr>
+              <a:buNone/>
+            </a:pPr>
+            <a:r>
+              <a:rPr lang="en-US" b="1" dirty="0">
+                <a:solidFill>
+                  <a:schemeClr val="tx1"/>
+                </a:solidFill>
+              </a:rPr>
+              <a:t>Object is </a:t>
+            </a:r>
+            <a:r>
+              <a:rPr lang="en-US" b="1" dirty="0" err="1">
+                <a:solidFill>
+                  <a:schemeClr val="tx1"/>
+                </a:solidFill>
+              </a:rPr>
+              <a:t>deserialized</a:t>
+            </a:r>
+            <a:r>
+              <a:rPr lang="en-US" b="1" dirty="0">
+                <a:solidFill>
+                  <a:schemeClr val="tx1"/>
+                </a:solidFill>
+              </a:rPr>
+              <a:t> using the following steps:</a:t>
+            </a:r>
+          </a:p>
+          <a:p>
+            <a:pPr>
+              <a:buNone/>
+            </a:pPr>
+            <a:endParaRPr lang="en-US" dirty="0">
+              <a:solidFill>
+                <a:schemeClr val="tx1"/>
+              </a:solidFill>
+            </a:endParaRPr>
+          </a:p>
+          <a:p>
+            <a:pPr>
+              <a:buNone/>
+            </a:pPr>
+            <a:r>
+              <a:rPr lang="en-US" dirty="0">
+                <a:solidFill>
+                  <a:schemeClr val="tx1"/>
+                </a:solidFill>
+              </a:rPr>
+              <a:t>1. Create a </a:t>
+            </a:r>
+            <a:r>
+              <a:rPr lang="en-US" sz="2000" dirty="0" err="1">
+                <a:solidFill>
+                  <a:schemeClr val="tx1"/>
+                </a:solidFill>
+                <a:latin typeface="Courier"/>
+                <a:cs typeface="Courier"/>
+              </a:rPr>
+              <a:t>FileInputStream</a:t>
+            </a:r>
+            <a:r>
+              <a:rPr lang="en-US" sz="2000" dirty="0">
+                <a:solidFill>
+                  <a:schemeClr val="tx1"/>
+                </a:solidFill>
+              </a:rPr>
+              <a:t> </a:t>
+            </a:r>
+            <a:r>
+              <a:rPr lang="en-US" dirty="0">
+                <a:solidFill>
+                  <a:schemeClr val="tx1"/>
+                </a:solidFill>
+              </a:rPr>
+              <a:t>to read from a file, </a:t>
+            </a:r>
+            <a:br>
+              <a:rPr lang="en-US" dirty="0">
+                <a:solidFill>
+                  <a:schemeClr val="tx1"/>
+                </a:solidFill>
+              </a:rPr>
+            </a:br>
+            <a:r>
+              <a:rPr lang="en-US" dirty="0">
+                <a:solidFill>
+                  <a:schemeClr val="tx1"/>
+                </a:solidFill>
+              </a:rPr>
+              <a:t>wrap it inside an </a:t>
+            </a:r>
+            <a:r>
+              <a:rPr lang="en-US" sz="2000" dirty="0" err="1">
+                <a:solidFill>
+                  <a:schemeClr val="tx1"/>
+                </a:solidFill>
+                <a:latin typeface="Courier"/>
+                <a:cs typeface="Courier"/>
+              </a:rPr>
+              <a:t>ObjectInputStream</a:t>
+            </a:r>
+            <a:r>
+              <a:rPr lang="en-US" dirty="0">
+                <a:solidFill>
+                  <a:schemeClr val="tx1"/>
+                </a:solidFill>
+              </a:rPr>
+              <a:t>.</a:t>
+            </a:r>
+          </a:p>
+          <a:p>
+            <a:pPr>
+              <a:buNone/>
+            </a:pPr>
+            <a:endParaRPr lang="en-US" dirty="0">
+              <a:solidFill>
+                <a:schemeClr val="tx1"/>
+              </a:solidFill>
+            </a:endParaRPr>
+          </a:p>
+          <a:p>
+            <a:pPr>
+              <a:buNone/>
+            </a:pPr>
+            <a:r>
+              <a:rPr lang="en-US" dirty="0">
+                <a:solidFill>
+                  <a:schemeClr val="tx1"/>
+                </a:solidFill>
+              </a:rPr>
+              <a:t>2. Invoke the object stream’s </a:t>
+            </a:r>
+            <a:r>
+              <a:rPr lang="en-US" sz="2000" dirty="0" err="1">
+                <a:solidFill>
+                  <a:schemeClr val="tx1"/>
+                </a:solidFill>
+                <a:latin typeface="Courier"/>
+                <a:cs typeface="Courier"/>
+              </a:rPr>
+              <a:t>readObject</a:t>
+            </a:r>
+            <a:r>
+              <a:rPr lang="en-US" sz="2000" dirty="0">
+                <a:solidFill>
+                  <a:schemeClr val="tx1"/>
+                </a:solidFill>
+              </a:rPr>
+              <a:t> </a:t>
+            </a:r>
+            <a:r>
+              <a:rPr lang="en-US" dirty="0">
+                <a:solidFill>
+                  <a:schemeClr val="tx1"/>
+                </a:solidFill>
+              </a:rPr>
+              <a:t>method, </a:t>
+            </a:r>
+            <a:br>
+              <a:rPr lang="en-US" dirty="0">
+                <a:solidFill>
+                  <a:schemeClr val="tx1"/>
+                </a:solidFill>
+              </a:rPr>
+            </a:br>
+            <a:r>
+              <a:rPr lang="en-US" dirty="0">
+                <a:solidFill>
+                  <a:schemeClr val="tx1"/>
+                </a:solidFill>
+              </a:rPr>
+              <a:t>to restore the object’s state.</a:t>
+            </a:r>
+          </a:p>
+        </p:txBody>
+      </p:sp>
+    </p:spTree>
+    <p:extLst>
+      <p:ext uri="{BB962C8B-B14F-4D97-AF65-F5344CB8AC3E}">
+        <p14:creationId xmlns:p14="http://schemas.microsoft.com/office/powerpoint/2010/main" val="1199201847"/>
+      </p:ext>
+    </p:extLst>
+  </p:cSld>
+  <p:clrMapOvr>
+    <a:masterClrMapping/>
+  </p:clrMapOvr>
+</p:sld>
+</file>
+
+<file path=ppt/slides/slide83.xml><?xml version="1.0" encoding="utf-8"?>
+<p:sld xmlns:a="http://schemas.openxmlformats.org/drawingml/2006/main" xmlns:r="http://schemas.openxmlformats.org/officeDocument/2006/relationships" xmlns:p="http://schemas.openxmlformats.org/presentationml/2006/main">
+  <p:cSld>
+    <p:spTree>
+      <p:nvGrpSpPr>
+        <p:cNvPr id="1" name=""/>
+        <p:cNvGrpSpPr/>
+        <p:nvPr/>
+      </p:nvGrpSpPr>
+      <p:grpSpPr>
+        <a:xfrm>
+          <a:off x="0" y="0"/>
+          <a:ext cx="0" cy="0"/>
+          <a:chOff x="0" y="0"/>
+          <a:chExt cx="0" cy="0"/>
+        </a:xfrm>
+      </p:grpSpPr>
+      <p:sp>
+        <p:nvSpPr>
+          <p:cNvPr id="2" name="Title 1"/>
+          <p:cNvSpPr>
+            <a:spLocks noGrp="1"/>
+          </p:cNvSpPr>
+          <p:nvPr>
+            <p:ph type="title"/>
+          </p:nvPr>
+        </p:nvSpPr>
+        <p:spPr>
+          <a:xfrm>
             <a:off x="936516" y="761649"/>
             <a:ext cx="7123151" cy="569197"/>
           </a:xfrm>
@@ -29273,7 +29430,7 @@
         <p:spPr>
           <a:xfrm>
             <a:off x="901341" y="0"/>
-            <a:ext cx="8098282" cy="360606"/>
+            <a:ext cx="10190212" cy="360606"/>
           </a:xfrm>
           <a:prstGeom prst="rect">
             <a:avLst/>
@@ -29286,7 +29443,7 @@
         </p:spPr>
         <p:txBody>
           <a:bodyPr vert="horz" lIns="91440" tIns="45720" rIns="91440" bIns="45720" rtlCol="0">
-            <a:normAutofit fontScale="55000" lnSpcReduction="20000"/>
+            <a:normAutofit fontScale="62500" lnSpcReduction="20000"/>
           </a:bodyPr>
           <a:lstStyle>
             <a:lvl1pPr marL="228600" indent="-228600" algn="l" defTabSz="914400" rtl="0" eaLnBrk="1" latinLnBrk="0" hangingPunct="1">
@@ -29479,6 +29636,41 @@
             </a:lvl9pPr>
           </a:lstStyle>
           <a:p>
+            <a:pPr marL="0" indent="0" algn="ctr">
+              <a:buNone/>
+              <a:defRPr/>
+            </a:pPr>
+            <a:r>
+              <a:rPr kumimoji="0" lang="en-US" sz="2600" b="0" i="0" u="none" strike="noStrike" kern="1200" cap="none" spc="0" normalizeH="0" baseline="0" noProof="0" dirty="0">
+                <a:ln>
+                  <a:noFill/>
+                </a:ln>
+                <a:solidFill>
+                  <a:srgbClr val="FF0000"/>
+                </a:solidFill>
+                <a:effectLst/>
+                <a:uLnTx/>
+                <a:uFillTx/>
+                <a:latin typeface="Arial" panose="020B0604020202020204"/>
+                <a:ea typeface="+mn-ea"/>
+              </a:rPr>
+              <a:t>CSEN160_06_Lecture_FileIO_AdvancedFileIO_Serialize.scu.csen160.AudioExample.</a:t>
+            </a:r>
+            <a:r>
+              <a:rPr lang="en-US" dirty="0" err="1">
+                <a:solidFill>
+                  <a:srgbClr val="FF0000"/>
+                </a:solidFill>
+              </a:rPr>
+              <a:t>D_AudioMixerSerialized</a:t>
+            </a:r>
+            <a:endParaRPr lang="en-US" dirty="0">
+              <a:solidFill>
+                <a:srgbClr val="FF0000"/>
+              </a:solidFill>
+            </a:endParaRPr>
+          </a:p>
+          <a:p>
             <a:pPr marL="0" marR="0" lvl="0" indent="0" algn="ctr" defTabSz="914400" rtl="0" eaLnBrk="1" fontAlgn="auto" latinLnBrk="0" hangingPunct="1">
               <a:lnSpc>
                 <a:spcPct val="90000"/>
@@ -29498,22 +29690,19 @@
               <a:tabLst/>
               <a:defRPr/>
             </a:pPr>
-            <a:r>
-              <a:rPr kumimoji="0" lang="en-US" sz="2600" b="0" i="0" u="none" strike="noStrike" kern="1200" cap="none" spc="0" normalizeH="0" baseline="0" noProof="0" dirty="0">
-                <a:ln>
-                  <a:noFill/>
-                </a:ln>
-                <a:solidFill>
-                  <a:srgbClr val="FF0000"/>
-                </a:solidFill>
-                <a:effectLst/>
-                <a:uLnTx/>
-                <a:uFillTx/>
-                <a:latin typeface="Arial" panose="020B0604020202020204"/>
-                <a:ea typeface="+mn-ea"/>
-              </a:rPr>
-              <a:t>“CSEN160_06_Lecture_FileIO_AdvancedFileIO_Serialize.scu.csen160.AudioMixerSerialized”</a:t>
-            </a:r>
+            <a:endParaRPr kumimoji="0" lang="en-US" sz="2600" b="0" i="0" u="none" strike="noStrike" kern="1200" cap="none" spc="0" normalizeH="0" baseline="0" noProof="0" dirty="0">
+              <a:ln>
+                <a:noFill/>
+              </a:ln>
+              <a:solidFill>
+                <a:srgbClr val="FF0000"/>
+              </a:solidFill>
+              <a:effectLst/>
+              <a:uLnTx/>
+              <a:uFillTx/>
+              <a:latin typeface="Arial" panose="020B0604020202020204"/>
+              <a:ea typeface="+mn-ea"/>
+            </a:endParaRPr>
           </a:p>
         </p:txBody>
       </p:sp>
@@ -29560,7 +29749,7 @@
 </p:sld>
 </file>
 
-<file path=ppt/slides/slide83.xml><?xml version="1.0" encoding="utf-8"?>
+<file path=ppt/slides/slide84.xml><?xml version="1.0" encoding="utf-8"?>
 <p:sld xmlns:a="http://schemas.openxmlformats.org/drawingml/2006/main" xmlns:r="http://schemas.openxmlformats.org/officeDocument/2006/relationships" xmlns:p="http://schemas.openxmlformats.org/presentationml/2006/main">
   <p:cSld>
     <p:spTree>
@@ -29812,70 +30001,6 @@
     <p:extLst>
       <p:ext uri="{BB962C8B-B14F-4D97-AF65-F5344CB8AC3E}">
         <p14:creationId xmlns:p14="http://schemas.microsoft.com/office/powerpoint/2010/main" val="3347800001"/>
-      </p:ext>
-    </p:extLst>
-  </p:cSld>
-  <p:clrMapOvr>
-    <a:masterClrMapping/>
-  </p:clrMapOvr>
-</p:sld>
-</file>
-
-<file path=ppt/slides/slide84.xml><?xml version="1.0" encoding="utf-8"?>
-<p:sld xmlns:a="http://schemas.openxmlformats.org/drawingml/2006/main" xmlns:r="http://schemas.openxmlformats.org/officeDocument/2006/relationships" xmlns:p="http://schemas.openxmlformats.org/presentationml/2006/main">
-  <p:cSld>
-    <p:spTree>
-      <p:nvGrpSpPr>
-        <p:cNvPr id="1" name="">
-          <a:extLst>
-            <a:ext uri="{FF2B5EF4-FFF2-40B4-BE49-F238E27FC236}">
-              <a16:creationId xmlns:a16="http://schemas.microsoft.com/office/drawing/2014/main" id="{84DA25F2-3AE0-BDCF-0880-EDD5EEF55E54}"/>
-            </a:ext>
-          </a:extLst>
-        </p:cNvPr>
-        <p:cNvGrpSpPr/>
-        <p:nvPr/>
-      </p:nvGrpSpPr>
-      <p:grpSpPr>
-        <a:xfrm>
-          <a:off x="0" y="0"/>
-          <a:ext cx="0" cy="0"/>
-          <a:chOff x="0" y="0"/>
-          <a:chExt cx="0" cy="0"/>
-        </a:xfrm>
-      </p:grpSpPr>
-      <p:sp>
-        <p:nvSpPr>
-          <p:cNvPr id="2" name="Title 1">
-            <a:extLst>
-              <a:ext uri="{FF2B5EF4-FFF2-40B4-BE49-F238E27FC236}">
-                <a16:creationId xmlns:a16="http://schemas.microsoft.com/office/drawing/2014/main" id="{6EAE57A2-3A61-C5F8-EEFD-EA2961784338}"/>
-              </a:ext>
-            </a:extLst>
-          </p:cNvPr>
-          <p:cNvSpPr>
-            <a:spLocks noGrp="1"/>
-          </p:cNvSpPr>
-          <p:nvPr>
-            <p:ph type="ctrTitle"/>
-          </p:nvPr>
-        </p:nvSpPr>
-        <p:spPr/>
-        <p:txBody>
-          <a:bodyPr/>
-          <a:lstStyle/>
-          <a:p>
-            <a:r>
-              <a:rPr lang="en-US" dirty="0"/>
-              <a:t>… to here …</a:t>
-            </a:r>
-          </a:p>
-        </p:txBody>
-      </p:sp>
-    </p:spTree>
-    <p:extLst>
-      <p:ext uri="{BB962C8B-B14F-4D97-AF65-F5344CB8AC3E}">
-        <p14:creationId xmlns:p14="http://schemas.microsoft.com/office/powerpoint/2010/main" val="2815624037"/>
       </p:ext>
     </p:extLst>
   </p:cSld>
@@ -30046,7 +30171,7 @@
         </p:nvSpPr>
         <p:spPr>
           <a:xfrm>
-            <a:off x="936516" y="0"/>
+            <a:off x="936516" y="7916"/>
             <a:ext cx="7391328" cy="360606"/>
           </a:xfrm>
           <a:prstGeom prst="rect">
@@ -30271,7 +30396,23 @@
                 <a:latin typeface="+mn-lt"/>
                 <a:ea typeface="+mn-ea"/>
               </a:rPr>
-              <a:t>“CSEN160_06_Lecture_FileIO_AdvancedFileIO_Serialize.scu.csen160.</a:t>
+              <a:t>CSEN160_06_Lecture_FileIO_AdvancedFileIO_Serialize.scu.csen160.</a:t>
+            </a:r>
+            <a:r>
+              <a:rPr lang="en-US" dirty="0">
+                <a:solidFill>
+                  <a:srgbClr val="FF0000"/>
+                </a:solidFill>
+              </a:rPr>
+              <a:t> </a:t>
+            </a:r>
+            <a:r>
+              <a:rPr lang="en-US" dirty="0" err="1">
+                <a:solidFill>
+                  <a:srgbClr val="FF0000"/>
+                </a:solidFill>
+              </a:rPr>
+              <a:t>FileIO.</a:t>
             </a:r>
             <a:r>
               <a:rPr lang="en-US" dirty="0" err="1">
@@ -30283,22 +30424,19 @@
               </a:rPr>
               <a:t>A_FileReaderExample</a:t>
             </a:r>
-            <a:r>
-              <a:rPr kumimoji="0" lang="en-US" sz="2600" b="0" i="0" u="none" strike="noStrike" kern="1200" cap="none" spc="0" normalizeH="0" baseline="0" noProof="0" dirty="0">
-                <a:ln>
-                  <a:noFill/>
-                </a:ln>
-                <a:solidFill>
-                  <a:srgbClr val="FF0000"/>
-                </a:solidFill>
-                <a:effectLst/>
-                <a:uLnTx/>
-                <a:uFillTx/>
-                <a:latin typeface="+mn-lt"/>
-                <a:ea typeface="+mn-ea"/>
-              </a:rPr>
-              <a:t>”</a:t>
-            </a:r>
+            <a:endParaRPr kumimoji="0" lang="en-US" sz="2600" b="0" i="0" u="none" strike="noStrike" kern="1200" cap="none" spc="0" normalizeH="0" baseline="0" noProof="0" dirty="0">
+              <a:ln>
+                <a:noFill/>
+              </a:ln>
+              <a:solidFill>
+                <a:srgbClr val="FF0000"/>
+              </a:solidFill>
+              <a:effectLst/>
+              <a:uLnTx/>
+              <a:uFillTx/>
+              <a:latin typeface="+mn-lt"/>
+              <a:ea typeface="+mn-ea"/>
+            </a:endParaRPr>
           </a:p>
         </p:txBody>
       </p:sp>

</xml_diff>

<commit_message>
Added some tiny add ones ...
</commit_message>
<xml_diff>
--- a/lectures/Week06_File_Threads/1_BasicFileIO_AdvFileIOandSerialize_V4.pptx
+++ b/lectures/Week06_File_Threads/1_BasicFileIO_AdvFileIOandSerialize_V4.pptx
@@ -25464,7 +25464,7 @@
                   <a:schemeClr val="tx1"/>
                 </a:solidFill>
               </a:rPr>
-              <a:t>Add an event handler: </a:t>
+              <a:t>Add event handler: </a:t>
             </a:r>
             <a:r>
               <a:rPr lang="en-US" sz="2000" dirty="0" err="1">
@@ -25542,7 +25542,7 @@
                   <a:schemeClr val="tx1"/>
                 </a:solidFill>
               </a:rPr>
-              <a:t>The interface </a:t>
+              <a:t>Interface </a:t>
             </a:r>
             <a:r>
               <a:rPr lang="en-US" sz="2000" dirty="0" err="1">
@@ -25742,7 +25742,7 @@
                   <a:schemeClr val="tx1"/>
                 </a:solidFill>
               </a:rPr>
-              <a:t>The event listener must implement this method </a:t>
+              <a:t>Event listener implements: </a:t>
             </a:r>
             <a:r>
               <a:rPr lang="en-US" sz="2000" dirty="0">
@@ -25752,16 +25752,33 @@
                 <a:latin typeface="Courier"/>
                 <a:cs typeface="Courier"/>
               </a:rPr>
-              <a:t>update</a:t>
-            </a:r>
-            <a:r>
-              <a:rPr lang="en-US" dirty="0">
-                <a:solidFill>
-                  <a:schemeClr val="tx1"/>
-                </a:solidFill>
-              </a:rPr>
-              <a:t>.</a:t>
-            </a:r>
+              <a:t>update(</a:t>
+            </a:r>
+            <a:r>
+              <a:rPr lang="en-US" sz="2000" dirty="0" err="1">
+                <a:solidFill>
+                  <a:schemeClr val="tx1"/>
+                </a:solidFill>
+                <a:latin typeface="Courier"/>
+                <a:cs typeface="Courier"/>
+              </a:rPr>
+              <a:t>LineEvent</a:t>
+            </a:r>
+            <a:r>
+              <a:rPr lang="en-US" sz="2000" dirty="0">
+                <a:solidFill>
+                  <a:schemeClr val="tx1"/>
+                </a:solidFill>
+                <a:latin typeface="Courier"/>
+                <a:cs typeface="Courier"/>
+              </a:rPr>
+              <a:t> event)</a:t>
+            </a:r>
+            <a:endParaRPr lang="en-US" dirty="0">
+              <a:solidFill>
+                <a:schemeClr val="tx1"/>
+              </a:solidFill>
+            </a:endParaRPr>
           </a:p>
           <a:p>
             <a:endParaRPr lang="en-US" dirty="0">
@@ -26841,7 +26858,7 @@
                   <a:schemeClr val="tx1"/>
                 </a:solidFill>
               </a:rPr>
-              <a:t>is constrained to lie within this range.</a:t>
+              <a:t>is constrained to be within this range.</a:t>
             </a:r>
           </a:p>
         </p:txBody>
@@ -27231,7 +27248,7 @@
         </p:blipFill>
         <p:spPr>
           <a:xfrm>
-            <a:off x="2595028" y="1806125"/>
+            <a:off x="2610862" y="1806125"/>
             <a:ext cx="7106433" cy="4612421"/>
           </a:xfrm>
           <a:prstGeom prst="rect">
@@ -27239,6 +27256,100 @@
           </a:prstGeom>
         </p:spPr>
       </p:pic>
+      <p:sp>
+        <p:nvSpPr>
+          <p:cNvPr id="3" name="TextBox 2">
+            <a:extLst>
+              <a:ext uri="{FF2B5EF4-FFF2-40B4-BE49-F238E27FC236}">
+                <a16:creationId xmlns:a16="http://schemas.microsoft.com/office/drawing/2014/main" id="{93FD3D82-4227-8257-2CB3-F155EAB2BEC5}"/>
+              </a:ext>
+            </a:extLst>
+          </p:cNvPr>
+          <p:cNvSpPr txBox="1"/>
+          <p:nvPr/>
+        </p:nvSpPr>
+        <p:spPr>
+          <a:xfrm>
+            <a:off x="7283533" y="3987002"/>
+            <a:ext cx="1018227" cy="369332"/>
+          </a:xfrm>
+          <a:prstGeom prst="rect">
+            <a:avLst/>
+          </a:prstGeom>
+          <a:noFill/>
+          <a:ln w="19050">
+            <a:solidFill>
+              <a:srgbClr val="FF0000"/>
+            </a:solidFill>
+          </a:ln>
+        </p:spPr>
+        <p:txBody>
+          <a:bodyPr wrap="none" rtlCol="0">
+            <a:spAutoFit/>
+          </a:bodyPr>
+          <a:lstStyle/>
+          <a:p>
+            <a:r>
+              <a:rPr lang="en-US" dirty="0"/>
+              <a:t>Clipping</a:t>
+            </a:r>
+          </a:p>
+        </p:txBody>
+      </p:sp>
+      <p:sp>
+        <p:nvSpPr>
+          <p:cNvPr id="6" name="Arrow: Right 5">
+            <a:extLst>
+              <a:ext uri="{FF2B5EF4-FFF2-40B4-BE49-F238E27FC236}">
+                <a16:creationId xmlns:a16="http://schemas.microsoft.com/office/drawing/2014/main" id="{F9659CCB-654B-39D3-AC06-64D12CA17EC6}"/>
+              </a:ext>
+            </a:extLst>
+          </p:cNvPr>
+          <p:cNvSpPr/>
+          <p:nvPr/>
+        </p:nvSpPr>
+        <p:spPr>
+          <a:xfrm rot="10800000">
+            <a:off x="6249707" y="3929352"/>
+            <a:ext cx="978408" cy="484632"/>
+          </a:xfrm>
+          <a:prstGeom prst="rightArrow">
+            <a:avLst/>
+          </a:prstGeom>
+          <a:solidFill>
+            <a:srgbClr val="FF0000"/>
+          </a:solidFill>
+          <a:ln>
+            <a:solidFill>
+              <a:srgbClr val="FF0000"/>
+            </a:solidFill>
+          </a:ln>
+        </p:spPr>
+        <p:style>
+          <a:lnRef idx="2">
+            <a:schemeClr val="accent1">
+              <a:shade val="15000"/>
+            </a:schemeClr>
+          </a:lnRef>
+          <a:fillRef idx="1">
+            <a:schemeClr val="accent1"/>
+          </a:fillRef>
+          <a:effectRef idx="0">
+            <a:schemeClr val="accent1"/>
+          </a:effectRef>
+          <a:fontRef idx="minor">
+            <a:schemeClr val="lt1"/>
+          </a:fontRef>
+        </p:style>
+        <p:txBody>
+          <a:bodyPr rtlCol="0" anchor="ctr"/>
+          <a:lstStyle/>
+          <a:p>
+            <a:pPr algn="ctr"/>
+            <a:endParaRPr lang="en-US"/>
+          </a:p>
+        </p:txBody>
+      </p:sp>
     </p:spTree>
     <p:extLst>
       <p:ext uri="{BB962C8B-B14F-4D97-AF65-F5344CB8AC3E}">
@@ -27415,7 +27526,7 @@
                   <a:schemeClr val="tx1"/>
                 </a:solidFill>
               </a:rPr>
-              <a:t>flattened/deflated. </a:t>
+              <a:t>flattened/deflated</a:t>
             </a:r>
           </a:p>
           <a:p>
@@ -27432,7 +27543,7 @@
                   <a:schemeClr val="tx1"/>
                 </a:solidFill>
               </a:rPr>
-              <a:t>The reverse of constructing an object back from the binary data is </a:t>
+              <a:t>Constructing an object back from binary data: </a:t>
             </a:r>
             <a:r>
               <a:rPr lang="en-US" b="1" dirty="0">
@@ -27440,7 +27551,7 @@
                   <a:schemeClr val="tx1"/>
                 </a:solidFill>
               </a:rPr>
-              <a:t>deserialization. </a:t>
+              <a:t>deserialization</a:t>
             </a:r>
           </a:p>
           <a:p>
@@ -27473,7 +27584,7 @@
                   <a:schemeClr val="tx1"/>
                 </a:solidFill>
               </a:rPr>
-              <a:t>object is one </a:t>
+              <a:t>object is one, </a:t>
             </a:r>
             <a:r>
               <a:rPr lang="en-US" b="1" dirty="0">
@@ -27483,14 +27594,11 @@
               </a:rPr>
               <a:t>whose state has been restored</a:t>
             </a:r>
-            <a:r>
-              <a:rPr lang="en-US" dirty="0">
-                <a:solidFill>
-                  <a:schemeClr val="tx1"/>
-                </a:solidFill>
-              </a:rPr>
-              <a:t>.</a:t>
-            </a:r>
+            <a:endParaRPr lang="en-US" dirty="0">
+              <a:solidFill>
+                <a:schemeClr val="tx1"/>
+              </a:solidFill>
+            </a:endParaRPr>
           </a:p>
         </p:txBody>
       </p:sp>

</xml_diff>